<commit_message>
Add final report and poster PDF for CMPE 492 project
</commit_message>
<xml_diff>
--- a/poster/CMPE492_POSTER.pptx
+++ b/poster/CMPE492_POSTER.pptx
@@ -3141,7 +3141,7 @@
         </p:nvSpPr>
         <p:spPr>
           <a:xfrm>
-            <a:off x="1666145" y="29644925"/>
+            <a:off x="36852" y="29837979"/>
             <a:ext cx="1937000" cy="554143"/>
           </a:xfrm>
           <a:prstGeom prst="rect">
@@ -3235,7 +3235,7 @@
         </p:blipFill>
         <p:spPr>
           <a:xfrm>
-            <a:off x="1691411" y="27746152"/>
+            <a:off x="62118" y="27939206"/>
             <a:ext cx="1937000" cy="1937000"/>
           </a:xfrm>
           <a:prstGeom prst="rect">
@@ -3803,7 +3803,7 @@
               <a:rPr lang="tr-TR" sz="2000" b="1" i="1" dirty="0">
                 <a:latin typeface="+mn-lt"/>
               </a:rPr>
-              <a:t>rearranged</a:t>
+              <a:t>remeshed</a:t>
             </a:r>
             <a:r>
               <a:rPr lang="en-US" sz="2000" b="1" i="1" dirty="0">
@@ -4157,201 +4157,301 @@
           </a:p>
         </p:txBody>
       </p:sp>
-      <p:sp>
-        <p:nvSpPr>
-          <p:cNvPr id="55" name="Text Box 189">
-            <a:extLst>
-              <a:ext uri="{FF2B5EF4-FFF2-40B4-BE49-F238E27FC236}">
-                <a16:creationId xmlns:a16="http://schemas.microsoft.com/office/drawing/2014/main" id="{698D4450-0A31-95D8-7924-271D02DCAF99}"/>
-              </a:ext>
-            </a:extLst>
-          </p:cNvPr>
-          <p:cNvSpPr txBox="1">
-            <a:spLocks noChangeArrowheads="1"/>
-          </p:cNvSpPr>
-          <p:nvPr/>
-        </p:nvSpPr>
-        <p:spPr bwMode="auto">
-          <a:xfrm>
-            <a:off x="1279896" y="20101130"/>
-            <a:ext cx="8754661" cy="3053810"/>
-          </a:xfrm>
-          <a:prstGeom prst="rect">
-            <a:avLst/>
-          </a:prstGeom>
-          <a:solidFill>
-            <a:schemeClr val="bg1"/>
-          </a:solidFill>
-          <a:ln w="12700">
-            <a:solidFill>
-              <a:schemeClr val="accent1">
-                <a:lumMod val="75000"/>
-              </a:schemeClr>
-            </a:solidFill>
-          </a:ln>
-          <a:effectLst/>
-        </p:spPr>
-        <p:txBody>
-          <a:bodyPr wrap="square" lIns="231978" tIns="231978" rIns="231978" bIns="231978">
-            <a:spAutoFit/>
-          </a:bodyPr>
-          <a:lstStyle>
-            <a:lvl1pPr eaLnBrk="0" hangingPunct="0">
-              <a:defRPr sz="2200">
-                <a:solidFill>
-                  <a:schemeClr val="tx1"/>
-                </a:solidFill>
-                <a:latin typeface="Arial" charset="0"/>
-              </a:defRPr>
-            </a:lvl1pPr>
-            <a:lvl2pPr marL="742950" indent="-285750" eaLnBrk="0" hangingPunct="0">
-              <a:defRPr sz="2200">
-                <a:solidFill>
-                  <a:schemeClr val="tx1"/>
-                </a:solidFill>
-                <a:latin typeface="Arial" charset="0"/>
-              </a:defRPr>
-            </a:lvl2pPr>
-            <a:lvl3pPr marL="1143000" indent="-228600" eaLnBrk="0" hangingPunct="0">
-              <a:defRPr sz="2200">
-                <a:solidFill>
-                  <a:schemeClr val="tx1"/>
-                </a:solidFill>
-                <a:latin typeface="Arial" charset="0"/>
-              </a:defRPr>
-            </a:lvl3pPr>
-            <a:lvl4pPr marL="1600200" indent="-228600" eaLnBrk="0" hangingPunct="0">
-              <a:defRPr sz="2200">
-                <a:solidFill>
-                  <a:schemeClr val="tx1"/>
-                </a:solidFill>
-                <a:latin typeface="Arial" charset="0"/>
-              </a:defRPr>
-            </a:lvl4pPr>
-            <a:lvl5pPr marL="2057400" indent="-228600" eaLnBrk="0" hangingPunct="0">
-              <a:defRPr sz="2200">
-                <a:solidFill>
-                  <a:schemeClr val="tx1"/>
-                </a:solidFill>
-                <a:latin typeface="Arial" charset="0"/>
-              </a:defRPr>
-            </a:lvl5pPr>
-            <a:lvl6pPr marL="2514600" indent="-228600" eaLnBrk="0" fontAlgn="base" hangingPunct="0">
-              <a:spcBef>
-                <a:spcPct val="0"/>
-              </a:spcBef>
-              <a:spcAft>
-                <a:spcPct val="0"/>
-              </a:spcAft>
-              <a:defRPr sz="2200">
-                <a:solidFill>
-                  <a:schemeClr val="tx1"/>
-                </a:solidFill>
-                <a:latin typeface="Arial" charset="0"/>
-              </a:defRPr>
-            </a:lvl6pPr>
-            <a:lvl7pPr marL="2971800" indent="-228600" eaLnBrk="0" fontAlgn="base" hangingPunct="0">
-              <a:spcBef>
-                <a:spcPct val="0"/>
-              </a:spcBef>
-              <a:spcAft>
-                <a:spcPct val="0"/>
-              </a:spcAft>
-              <a:defRPr sz="2200">
-                <a:solidFill>
-                  <a:schemeClr val="tx1"/>
-                </a:solidFill>
-                <a:latin typeface="Arial" charset="0"/>
-              </a:defRPr>
-            </a:lvl7pPr>
-            <a:lvl8pPr marL="3429000" indent="-228600" eaLnBrk="0" fontAlgn="base" hangingPunct="0">
-              <a:spcBef>
-                <a:spcPct val="0"/>
-              </a:spcBef>
-              <a:spcAft>
-                <a:spcPct val="0"/>
-              </a:spcAft>
-              <a:defRPr sz="2200">
-                <a:solidFill>
-                  <a:schemeClr val="tx1"/>
-                </a:solidFill>
-                <a:latin typeface="Arial" charset="0"/>
-              </a:defRPr>
-            </a:lvl8pPr>
-            <a:lvl9pPr marL="3886200" indent="-228600" eaLnBrk="0" fontAlgn="base" hangingPunct="0">
-              <a:spcBef>
-                <a:spcPct val="0"/>
-              </a:spcBef>
-              <a:spcAft>
-                <a:spcPct val="0"/>
-              </a:spcAft>
-              <a:defRPr sz="2200">
-                <a:solidFill>
-                  <a:schemeClr val="tx1"/>
-                </a:solidFill>
-                <a:latin typeface="Arial" charset="0"/>
-              </a:defRPr>
-            </a:lvl9pPr>
-          </a:lstStyle>
-          <a:p>
-            <a:pPr eaLnBrk="1" hangingPunct="1"/>
-            <a:r>
-              <a:rPr lang="" sz="2000" dirty="0">
-                <a:latin typeface="+mn-lt"/>
-              </a:rPr>
-              <a:t>• Antibodies immobilized on graphene selectively bind HER2 antigens.</a:t>
-            </a:r>
-            <a:br>
-              <a:rPr lang="" sz="2000" dirty="0">
-                <a:latin typeface="+mn-lt"/>
-              </a:rPr>
-            </a:br>
-            <a:r>
-              <a:rPr lang="" sz="2000" dirty="0">
-                <a:latin typeface="+mn-lt"/>
-              </a:rPr>
-              <a:t>• Bound HER2 changes the local electrostatic environment near the graphene channel.</a:t>
-            </a:r>
-            <a:br>
-              <a:rPr lang="" sz="2000" dirty="0">
-                <a:latin typeface="+mn-lt"/>
-              </a:rPr>
-            </a:br>
-            <a:r>
-              <a:rPr lang="" sz="2000" dirty="0">
-                <a:latin typeface="+mn-lt"/>
-              </a:rPr>
-              <a:t>• This perturbation changes the drain-source current, ΔIDS.</a:t>
-            </a:r>
-            <a:br>
-              <a:rPr lang="" sz="2000" dirty="0">
-                <a:latin typeface="+mn-lt"/>
-              </a:rPr>
-            </a:br>
-            <a:r>
-              <a:rPr lang="" sz="2000" dirty="0">
-                <a:latin typeface="+mn-lt"/>
-              </a:rPr>
-              <a:t>• The signal is modeled analytically from bound molecule count and coupling efficiency.</a:t>
-            </a:r>
-            <a:endParaRPr lang="tr-TR" sz="2000" dirty="0">
-              <a:latin typeface="+mn-lt"/>
-            </a:endParaRPr>
-          </a:p>
-          <a:p>
-            <a:pPr eaLnBrk="1" hangingPunct="1"/>
-            <a:endParaRPr lang="tr-TR" sz="2400" dirty="0">
-              <a:latin typeface="+mn-lt"/>
-            </a:endParaRPr>
-          </a:p>
-          <a:p>
-            <a:pPr eaLnBrk="1" hangingPunct="1"/>
-            <a:endParaRPr lang="en-US" sz="2400" dirty="0">
-              <a:latin typeface="+mn-lt"/>
-            </a:endParaRPr>
-          </a:p>
-        </p:txBody>
-      </p:sp>
+      <mc:AlternateContent xmlns:mc="http://schemas.openxmlformats.org/markup-compatibility/2006">
+        <mc:Choice xmlns:a14="http://schemas.microsoft.com/office/drawing/2010/main" Requires="a14">
+          <p:sp>
+            <p:nvSpPr>
+              <p:cNvPr id="55" name="Text Box 189">
+                <a:extLst>
+                  <a:ext uri="{FF2B5EF4-FFF2-40B4-BE49-F238E27FC236}">
+                    <a16:creationId xmlns:a16="http://schemas.microsoft.com/office/drawing/2014/main" id="{698D4450-0A31-95D8-7924-271D02DCAF99}"/>
+                  </a:ext>
+                </a:extLst>
+              </p:cNvPr>
+              <p:cNvSpPr txBox="1">
+                <a:spLocks noChangeArrowheads="1"/>
+              </p:cNvSpPr>
+              <p:nvPr/>
+            </p:nvSpPr>
+            <p:spPr bwMode="auto">
+              <a:xfrm>
+                <a:off x="1279896" y="20101130"/>
+                <a:ext cx="8754661" cy="3053810"/>
+              </a:xfrm>
+              <a:prstGeom prst="rect">
+                <a:avLst/>
+              </a:prstGeom>
+              <a:solidFill>
+                <a:schemeClr val="bg1"/>
+              </a:solidFill>
+              <a:ln w="12700">
+                <a:solidFill>
+                  <a:schemeClr val="accent1">
+                    <a:lumMod val="75000"/>
+                  </a:schemeClr>
+                </a:solidFill>
+              </a:ln>
+              <a:effectLst/>
+            </p:spPr>
+            <p:txBody>
+              <a:bodyPr wrap="square" lIns="231978" tIns="231978" rIns="231978" bIns="231978">
+                <a:spAutoFit/>
+              </a:bodyPr>
+              <a:lstStyle>
+                <a:lvl1pPr eaLnBrk="0" hangingPunct="0">
+                  <a:defRPr sz="2200">
+                    <a:solidFill>
+                      <a:schemeClr val="tx1"/>
+                    </a:solidFill>
+                    <a:latin typeface="Arial" charset="0"/>
+                  </a:defRPr>
+                </a:lvl1pPr>
+                <a:lvl2pPr marL="742950" indent="-285750" eaLnBrk="0" hangingPunct="0">
+                  <a:defRPr sz="2200">
+                    <a:solidFill>
+                      <a:schemeClr val="tx1"/>
+                    </a:solidFill>
+                    <a:latin typeface="Arial" charset="0"/>
+                  </a:defRPr>
+                </a:lvl2pPr>
+                <a:lvl3pPr marL="1143000" indent="-228600" eaLnBrk="0" hangingPunct="0">
+                  <a:defRPr sz="2200">
+                    <a:solidFill>
+                      <a:schemeClr val="tx1"/>
+                    </a:solidFill>
+                    <a:latin typeface="Arial" charset="0"/>
+                  </a:defRPr>
+                </a:lvl3pPr>
+                <a:lvl4pPr marL="1600200" indent="-228600" eaLnBrk="0" hangingPunct="0">
+                  <a:defRPr sz="2200">
+                    <a:solidFill>
+                      <a:schemeClr val="tx1"/>
+                    </a:solidFill>
+                    <a:latin typeface="Arial" charset="0"/>
+                  </a:defRPr>
+                </a:lvl4pPr>
+                <a:lvl5pPr marL="2057400" indent="-228600" eaLnBrk="0" hangingPunct="0">
+                  <a:defRPr sz="2200">
+                    <a:solidFill>
+                      <a:schemeClr val="tx1"/>
+                    </a:solidFill>
+                    <a:latin typeface="Arial" charset="0"/>
+                  </a:defRPr>
+                </a:lvl5pPr>
+                <a:lvl6pPr marL="2514600" indent="-228600" eaLnBrk="0" fontAlgn="base" hangingPunct="0">
+                  <a:spcBef>
+                    <a:spcPct val="0"/>
+                  </a:spcBef>
+                  <a:spcAft>
+                    <a:spcPct val="0"/>
+                  </a:spcAft>
+                  <a:defRPr sz="2200">
+                    <a:solidFill>
+                      <a:schemeClr val="tx1"/>
+                    </a:solidFill>
+                    <a:latin typeface="Arial" charset="0"/>
+                  </a:defRPr>
+                </a:lvl6pPr>
+                <a:lvl7pPr marL="2971800" indent="-228600" eaLnBrk="0" fontAlgn="base" hangingPunct="0">
+                  <a:spcBef>
+                    <a:spcPct val="0"/>
+                  </a:spcBef>
+                  <a:spcAft>
+                    <a:spcPct val="0"/>
+                  </a:spcAft>
+                  <a:defRPr sz="2200">
+                    <a:solidFill>
+                      <a:schemeClr val="tx1"/>
+                    </a:solidFill>
+                    <a:latin typeface="Arial" charset="0"/>
+                  </a:defRPr>
+                </a:lvl7pPr>
+                <a:lvl8pPr marL="3429000" indent="-228600" eaLnBrk="0" fontAlgn="base" hangingPunct="0">
+                  <a:spcBef>
+                    <a:spcPct val="0"/>
+                  </a:spcBef>
+                  <a:spcAft>
+                    <a:spcPct val="0"/>
+                  </a:spcAft>
+                  <a:defRPr sz="2200">
+                    <a:solidFill>
+                      <a:schemeClr val="tx1"/>
+                    </a:solidFill>
+                    <a:latin typeface="Arial" charset="0"/>
+                  </a:defRPr>
+                </a:lvl8pPr>
+                <a:lvl9pPr marL="3886200" indent="-228600" eaLnBrk="0" fontAlgn="base" hangingPunct="0">
+                  <a:spcBef>
+                    <a:spcPct val="0"/>
+                  </a:spcBef>
+                  <a:spcAft>
+                    <a:spcPct val="0"/>
+                  </a:spcAft>
+                  <a:defRPr sz="2200">
+                    <a:solidFill>
+                      <a:schemeClr val="tx1"/>
+                    </a:solidFill>
+                    <a:latin typeface="Arial" charset="0"/>
+                  </a:defRPr>
+                </a:lvl9pPr>
+              </a:lstStyle>
+              <a:p>
+                <a:pPr eaLnBrk="1" hangingPunct="1"/>
+                <a:r>
+                  <a:rPr lang="" sz="2000" dirty="0">
+                    <a:latin typeface="+mn-lt"/>
+                  </a:rPr>
+                  <a:t>• Antibodies immobilized on graphene selectively bind HER2 antigens.</a:t>
+                </a:r>
+                <a:br>
+                  <a:rPr lang="" sz="2000" dirty="0">
+                    <a:latin typeface="+mn-lt"/>
+                  </a:rPr>
+                </a:br>
+                <a:r>
+                  <a:rPr lang="" sz="2000" dirty="0">
+                    <a:latin typeface="+mn-lt"/>
+                  </a:rPr>
+                  <a:t>• Bound HER2 changes the local electrostatic environment near the graphene channel.</a:t>
+                </a:r>
+                <a:br>
+                  <a:rPr lang="" sz="2000" dirty="0">
+                    <a:latin typeface="+mn-lt"/>
+                  </a:rPr>
+                </a:br>
+                <a:r>
+                  <a:rPr lang="" sz="2000" dirty="0">
+                    <a:latin typeface="+mn-lt"/>
+                  </a:rPr>
+                  <a:t>• This perturbation changes the drain-source current, </a:t>
+                </a:r>
+                <a14:m>
+                  <m:oMath xmlns:m="http://schemas.openxmlformats.org/officeDocument/2006/math">
+                    <m:r>
+                      <m:rPr>
+                        <m:sty m:val="p"/>
+                      </m:rPr>
+                      <a:rPr lang="LID4096" sz="2000" i="0" smtClean="0">
+                        <a:latin typeface="Cambria Math" panose="02040503050406030204" pitchFamily="18" charset="0"/>
+                      </a:rPr>
+                      <m:t>Δ</m:t>
+                    </m:r>
+                    <m:sSub>
+                      <m:sSubPr>
+                        <m:ctrlPr>
+                          <a:rPr lang="LID4096" sz="2000" i="1" smtClean="0">
+                            <a:latin typeface="Cambria Math" panose="02040503050406030204" pitchFamily="18" charset="0"/>
+                          </a:rPr>
+                        </m:ctrlPr>
+                      </m:sSubPr>
+                      <m:e>
+                        <m:r>
+                          <a:rPr lang="LID4096" sz="2000" i="1" smtClean="0">
+                            <a:latin typeface="Cambria Math" panose="02040503050406030204" pitchFamily="18" charset="0"/>
+                          </a:rPr>
+                          <m:t>𝐼</m:t>
+                        </m:r>
+                      </m:e>
+                      <m:sub>
+                        <m:r>
+                          <a:rPr lang="LID4096" sz="2000" i="1" smtClean="0">
+                            <a:latin typeface="Cambria Math" panose="02040503050406030204" pitchFamily="18" charset="0"/>
+                          </a:rPr>
+                          <m:t>𝐷𝑆</m:t>
+                        </m:r>
+                      </m:sub>
+                    </m:sSub>
+                  </m:oMath>
+                </a14:m>
+                <a:r>
+                  <a:rPr lang="" sz="2000" dirty="0">
+                    <a:latin typeface="+mn-lt"/>
+                  </a:rPr>
+                  <a:t>.</a:t>
+                </a:r>
+                <a:br>
+                  <a:rPr lang="" sz="2000" dirty="0">
+                    <a:latin typeface="+mn-lt"/>
+                  </a:rPr>
+                </a:br>
+                <a:r>
+                  <a:rPr lang="" sz="2000" dirty="0">
+                    <a:latin typeface="+mn-lt"/>
+                  </a:rPr>
+                  <a:t>• The signal is modeled analytically from bound molecule count and coupling efficiency.</a:t>
+                </a:r>
+                <a:endParaRPr lang="tr-TR" sz="2000" dirty="0">
+                  <a:latin typeface="+mn-lt"/>
+                </a:endParaRPr>
+              </a:p>
+              <a:p>
+                <a:pPr eaLnBrk="1" hangingPunct="1"/>
+                <a:endParaRPr lang="tr-TR" sz="2400" dirty="0">
+                  <a:latin typeface="+mn-lt"/>
+                </a:endParaRPr>
+              </a:p>
+              <a:p>
+                <a:pPr eaLnBrk="1" hangingPunct="1"/>
+                <a:endParaRPr lang="en-US" sz="2400" dirty="0">
+                  <a:latin typeface="+mn-lt"/>
+                </a:endParaRPr>
+              </a:p>
+            </p:txBody>
+          </p:sp>
+        </mc:Choice>
+        <mc:Fallback>
+          <p:sp>
+            <p:nvSpPr>
+              <p:cNvPr id="55" name="Text Box 189">
+                <a:extLst>
+                  <a:ext uri="{FF2B5EF4-FFF2-40B4-BE49-F238E27FC236}">
+                    <a16:creationId xmlns:a16="http://schemas.microsoft.com/office/drawing/2014/main" id="{698D4450-0A31-95D8-7924-271D02DCAF99}"/>
+                  </a:ext>
+                </a:extLst>
+              </p:cNvPr>
+              <p:cNvSpPr txBox="1">
+                <a:spLocks noRot="1" noChangeAspect="1" noMove="1" noResize="1" noEditPoints="1" noAdjustHandles="1" noChangeArrowheads="1" noChangeShapeType="1" noTextEdit="1"/>
+              </p:cNvSpPr>
+              <p:nvPr/>
+            </p:nvSpPr>
+            <p:spPr bwMode="auto">
+              <a:xfrm>
+                <a:off x="1279896" y="20101130"/>
+                <a:ext cx="8754661" cy="3053810"/>
+              </a:xfrm>
+              <a:prstGeom prst="rect">
+                <a:avLst/>
+              </a:prstGeom>
+              <a:blipFill>
+                <a:blip r:embed="rId4"/>
+                <a:stretch>
+                  <a:fillRect/>
+                </a:stretch>
+              </a:blipFill>
+              <a:ln w="12700">
+                <a:solidFill>
+                  <a:schemeClr val="accent1">
+                    <a:lumMod val="75000"/>
+                  </a:schemeClr>
+                </a:solidFill>
+              </a:ln>
+              <a:effectLst/>
+            </p:spPr>
+            <p:txBody>
+              <a:bodyPr/>
+              <a:lstStyle/>
+              <a:p>
+                <a:r>
+                  <a:rPr lang="LID4096">
+                    <a:noFill/>
+                  </a:rPr>
+                  <a:t> </a:t>
+                </a:r>
+              </a:p>
+            </p:txBody>
+          </p:sp>
+        </mc:Fallback>
+      </mc:AlternateContent>
       <p:sp>
         <p:nvSpPr>
           <p:cNvPr id="67" name="Text Box 123">
@@ -4543,7 +4643,7 @@
           <p:nvPr/>
         </p:nvPicPr>
         <p:blipFill>
-          <a:blip r:embed="rId4"/>
+          <a:blip r:embed="rId5"/>
           <a:stretch>
             <a:fillRect/>
           </a:stretch>
@@ -4573,7 +4673,7 @@
           <p:nvPr/>
         </p:nvPicPr>
         <p:blipFill>
-          <a:blip r:embed="rId5"/>
+          <a:blip r:embed="rId6"/>
           <a:stretch>
             <a:fillRect/>
           </a:stretch>
@@ -4603,7 +4703,7 @@
           <p:nvPr/>
         </p:nvPicPr>
         <p:blipFill>
-          <a:blip r:embed="rId6"/>
+          <a:blip r:embed="rId7"/>
           <a:stretch>
             <a:fillRect/>
           </a:stretch>
@@ -4699,222 +4799,313 @@
           </a:p>
         </p:txBody>
       </p:sp>
-      <p:sp>
-        <p:nvSpPr>
-          <p:cNvPr id="79" name="Text Box 189">
-            <a:extLst>
-              <a:ext uri="{FF2B5EF4-FFF2-40B4-BE49-F238E27FC236}">
-                <a16:creationId xmlns:a16="http://schemas.microsoft.com/office/drawing/2014/main" id="{4E3A54A1-9206-0340-2930-030FCADCBC18}"/>
-              </a:ext>
-            </a:extLst>
-          </p:cNvPr>
-          <p:cNvSpPr txBox="1">
-            <a:spLocks noChangeArrowheads="1"/>
-          </p:cNvSpPr>
-          <p:nvPr/>
-        </p:nvSpPr>
-        <p:spPr bwMode="auto">
-          <a:xfrm>
-            <a:off x="22299897" y="10786366"/>
-            <a:ext cx="8787392" cy="2315146"/>
-          </a:xfrm>
-          <a:prstGeom prst="rect">
-            <a:avLst/>
-          </a:prstGeom>
-          <a:solidFill>
-            <a:schemeClr val="bg1"/>
-          </a:solidFill>
-          <a:ln w="12700">
-            <a:solidFill>
-              <a:schemeClr val="accent1">
-                <a:lumMod val="75000"/>
-              </a:schemeClr>
-            </a:solidFill>
-          </a:ln>
-          <a:effectLst/>
-        </p:spPr>
-        <p:txBody>
-          <a:bodyPr wrap="square" lIns="231978" tIns="231978" rIns="231978" bIns="231978">
-            <a:spAutoFit/>
-          </a:bodyPr>
-          <a:lstStyle>
-            <a:lvl1pPr eaLnBrk="0" hangingPunct="0">
-              <a:defRPr sz="2200">
-                <a:solidFill>
-                  <a:schemeClr val="tx1"/>
-                </a:solidFill>
-                <a:latin typeface="Arial" charset="0"/>
-              </a:defRPr>
-            </a:lvl1pPr>
-            <a:lvl2pPr marL="742950" indent="-285750" eaLnBrk="0" hangingPunct="0">
-              <a:defRPr sz="2200">
-                <a:solidFill>
-                  <a:schemeClr val="tx1"/>
-                </a:solidFill>
-                <a:latin typeface="Arial" charset="0"/>
-              </a:defRPr>
-            </a:lvl2pPr>
-            <a:lvl3pPr marL="1143000" indent="-228600" eaLnBrk="0" hangingPunct="0">
-              <a:defRPr sz="2200">
-                <a:solidFill>
-                  <a:schemeClr val="tx1"/>
-                </a:solidFill>
-                <a:latin typeface="Arial" charset="0"/>
-              </a:defRPr>
-            </a:lvl3pPr>
-            <a:lvl4pPr marL="1600200" indent="-228600" eaLnBrk="0" hangingPunct="0">
-              <a:defRPr sz="2200">
-                <a:solidFill>
-                  <a:schemeClr val="tx1"/>
-                </a:solidFill>
-                <a:latin typeface="Arial" charset="0"/>
-              </a:defRPr>
-            </a:lvl4pPr>
-            <a:lvl5pPr marL="2057400" indent="-228600" eaLnBrk="0" hangingPunct="0">
-              <a:defRPr sz="2200">
-                <a:solidFill>
-                  <a:schemeClr val="tx1"/>
-                </a:solidFill>
-                <a:latin typeface="Arial" charset="0"/>
-              </a:defRPr>
-            </a:lvl5pPr>
-            <a:lvl6pPr marL="2514600" indent="-228600" eaLnBrk="0" fontAlgn="base" hangingPunct="0">
-              <a:spcBef>
-                <a:spcPct val="0"/>
-              </a:spcBef>
-              <a:spcAft>
-                <a:spcPct val="0"/>
-              </a:spcAft>
-              <a:defRPr sz="2200">
-                <a:solidFill>
-                  <a:schemeClr val="tx1"/>
-                </a:solidFill>
-                <a:latin typeface="Arial" charset="0"/>
-              </a:defRPr>
-            </a:lvl6pPr>
-            <a:lvl7pPr marL="2971800" indent="-228600" eaLnBrk="0" fontAlgn="base" hangingPunct="0">
-              <a:spcBef>
-                <a:spcPct val="0"/>
-              </a:spcBef>
-              <a:spcAft>
-                <a:spcPct val="0"/>
-              </a:spcAft>
-              <a:defRPr sz="2200">
-                <a:solidFill>
-                  <a:schemeClr val="tx1"/>
-                </a:solidFill>
-                <a:latin typeface="Arial" charset="0"/>
-              </a:defRPr>
-            </a:lvl7pPr>
-            <a:lvl8pPr marL="3429000" indent="-228600" eaLnBrk="0" fontAlgn="base" hangingPunct="0">
-              <a:spcBef>
-                <a:spcPct val="0"/>
-              </a:spcBef>
-              <a:spcAft>
-                <a:spcPct val="0"/>
-              </a:spcAft>
-              <a:defRPr sz="2200">
-                <a:solidFill>
-                  <a:schemeClr val="tx1"/>
-                </a:solidFill>
-                <a:latin typeface="Arial" charset="0"/>
-              </a:defRPr>
-            </a:lvl8pPr>
-            <a:lvl9pPr marL="3886200" indent="-228600" eaLnBrk="0" fontAlgn="base" hangingPunct="0">
-              <a:spcBef>
-                <a:spcPct val="0"/>
-              </a:spcBef>
-              <a:spcAft>
-                <a:spcPct val="0"/>
-              </a:spcAft>
-              <a:defRPr sz="2200">
-                <a:solidFill>
-                  <a:schemeClr val="tx1"/>
-                </a:solidFill>
-                <a:latin typeface="Arial" charset="0"/>
-              </a:defRPr>
-            </a:lvl9pPr>
-          </a:lstStyle>
-          <a:p>
-            <a:pPr eaLnBrk="1" hangingPunct="1"/>
-            <a:r>
-              <a:rPr lang="" sz="2000" dirty="0">
-                <a:latin typeface="+mn-lt"/>
-              </a:rPr>
-              <a:t>• At 10 pM HER2, diffusion-only transport gives 4.98 pM sensor concentration at 6000 s.</a:t>
-            </a:r>
-            <a:br>
-              <a:rPr lang="" sz="2000" dirty="0">
-                <a:latin typeface="+mn-lt"/>
-              </a:rPr>
-            </a:br>
-            <a:r>
-              <a:rPr lang="" sz="2000" dirty="0">
-                <a:latin typeface="+mn-lt"/>
-              </a:rPr>
-              <a:t>• Reference flow, vin = 5 × 10⁻⁷ m/s, gives 8.73 pM at 6000 s.</a:t>
-            </a:r>
-            <a:br>
-              <a:rPr lang="" sz="2000" dirty="0">
-                <a:latin typeface="+mn-lt"/>
-              </a:rPr>
-            </a:br>
-            <a:r>
-              <a:rPr lang="" sz="2000" dirty="0">
-                <a:latin typeface="+mn-lt"/>
-              </a:rPr>
-              <a:t>• This corresponds to approximately 1.75× higher late-time exposure.</a:t>
-            </a:r>
-            <a:br>
-              <a:rPr lang="" sz="2000" dirty="0">
-                <a:latin typeface="+mn-lt"/>
-              </a:rPr>
-            </a:br>
-            <a:r>
-              <a:rPr lang="" sz="2000" dirty="0">
-                <a:latin typeface="+mn-lt"/>
-              </a:rPr>
-              <a:t>• Time</a:t>
-            </a:r>
-            <a:r>
-              <a:rPr lang="tr-TR" sz="2000" dirty="0">
-                <a:latin typeface="+mn-lt"/>
-              </a:rPr>
-              <a:t> </a:t>
-            </a:r>
-            <a:r>
-              <a:rPr lang="" sz="2000" dirty="0">
-                <a:latin typeface="+mn-lt"/>
-              </a:rPr>
-              <a:t>to</a:t>
-            </a:r>
-            <a:r>
-              <a:rPr lang="tr-TR" sz="2000" dirty="0">
-                <a:latin typeface="+mn-lt"/>
-              </a:rPr>
-              <a:t> </a:t>
-            </a:r>
-            <a:r>
-              <a:rPr lang="" sz="2000" dirty="0">
-                <a:latin typeface="+mn-lt"/>
-              </a:rPr>
-              <a:t>50% exposure decreases from 6038 s to 1839 s.</a:t>
-            </a:r>
-            <a:endParaRPr lang="tr-TR" sz="2000" dirty="0">
-              <a:latin typeface="+mn-lt"/>
-            </a:endParaRPr>
-          </a:p>
-          <a:p>
-            <a:pPr eaLnBrk="1" hangingPunct="1"/>
-            <a:r>
-              <a:rPr lang="en-US" sz="2000" b="1" i="1" dirty="0">
-                <a:latin typeface="+mn-lt"/>
-              </a:rPr>
-              <a:t>Flow improves exposure, but transport is only the first bottleneck.</a:t>
-            </a:r>
-          </a:p>
-        </p:txBody>
-      </p:sp>
+      <mc:AlternateContent xmlns:mc="http://schemas.openxmlformats.org/markup-compatibility/2006">
+        <mc:Choice xmlns:a14="http://schemas.microsoft.com/office/drawing/2010/main" Requires="a14">
+          <p:sp>
+            <p:nvSpPr>
+              <p:cNvPr id="79" name="Text Box 189">
+                <a:extLst>
+                  <a:ext uri="{FF2B5EF4-FFF2-40B4-BE49-F238E27FC236}">
+                    <a16:creationId xmlns:a16="http://schemas.microsoft.com/office/drawing/2014/main" id="{4E3A54A1-9206-0340-2930-030FCADCBC18}"/>
+                  </a:ext>
+                </a:extLst>
+              </p:cNvPr>
+              <p:cNvSpPr txBox="1">
+                <a:spLocks noChangeArrowheads="1"/>
+              </p:cNvSpPr>
+              <p:nvPr/>
+            </p:nvSpPr>
+            <p:spPr bwMode="auto">
+              <a:xfrm>
+                <a:off x="22299897" y="10786366"/>
+                <a:ext cx="8787392" cy="2315146"/>
+              </a:xfrm>
+              <a:prstGeom prst="rect">
+                <a:avLst/>
+              </a:prstGeom>
+              <a:solidFill>
+                <a:schemeClr val="bg1"/>
+              </a:solidFill>
+              <a:ln w="12700">
+                <a:solidFill>
+                  <a:schemeClr val="accent1">
+                    <a:lumMod val="75000"/>
+                  </a:schemeClr>
+                </a:solidFill>
+              </a:ln>
+              <a:effectLst/>
+            </p:spPr>
+            <p:txBody>
+              <a:bodyPr wrap="square" lIns="231978" tIns="231978" rIns="231978" bIns="231978">
+                <a:spAutoFit/>
+              </a:bodyPr>
+              <a:lstStyle>
+                <a:lvl1pPr eaLnBrk="0" hangingPunct="0">
+                  <a:defRPr sz="2200">
+                    <a:solidFill>
+                      <a:schemeClr val="tx1"/>
+                    </a:solidFill>
+                    <a:latin typeface="Arial" charset="0"/>
+                  </a:defRPr>
+                </a:lvl1pPr>
+                <a:lvl2pPr marL="742950" indent="-285750" eaLnBrk="0" hangingPunct="0">
+                  <a:defRPr sz="2200">
+                    <a:solidFill>
+                      <a:schemeClr val="tx1"/>
+                    </a:solidFill>
+                    <a:latin typeface="Arial" charset="0"/>
+                  </a:defRPr>
+                </a:lvl2pPr>
+                <a:lvl3pPr marL="1143000" indent="-228600" eaLnBrk="0" hangingPunct="0">
+                  <a:defRPr sz="2200">
+                    <a:solidFill>
+                      <a:schemeClr val="tx1"/>
+                    </a:solidFill>
+                    <a:latin typeface="Arial" charset="0"/>
+                  </a:defRPr>
+                </a:lvl3pPr>
+                <a:lvl4pPr marL="1600200" indent="-228600" eaLnBrk="0" hangingPunct="0">
+                  <a:defRPr sz="2200">
+                    <a:solidFill>
+                      <a:schemeClr val="tx1"/>
+                    </a:solidFill>
+                    <a:latin typeface="Arial" charset="0"/>
+                  </a:defRPr>
+                </a:lvl4pPr>
+                <a:lvl5pPr marL="2057400" indent="-228600" eaLnBrk="0" hangingPunct="0">
+                  <a:defRPr sz="2200">
+                    <a:solidFill>
+                      <a:schemeClr val="tx1"/>
+                    </a:solidFill>
+                    <a:latin typeface="Arial" charset="0"/>
+                  </a:defRPr>
+                </a:lvl5pPr>
+                <a:lvl6pPr marL="2514600" indent="-228600" eaLnBrk="0" fontAlgn="base" hangingPunct="0">
+                  <a:spcBef>
+                    <a:spcPct val="0"/>
+                  </a:spcBef>
+                  <a:spcAft>
+                    <a:spcPct val="0"/>
+                  </a:spcAft>
+                  <a:defRPr sz="2200">
+                    <a:solidFill>
+                      <a:schemeClr val="tx1"/>
+                    </a:solidFill>
+                    <a:latin typeface="Arial" charset="0"/>
+                  </a:defRPr>
+                </a:lvl6pPr>
+                <a:lvl7pPr marL="2971800" indent="-228600" eaLnBrk="0" fontAlgn="base" hangingPunct="0">
+                  <a:spcBef>
+                    <a:spcPct val="0"/>
+                  </a:spcBef>
+                  <a:spcAft>
+                    <a:spcPct val="0"/>
+                  </a:spcAft>
+                  <a:defRPr sz="2200">
+                    <a:solidFill>
+                      <a:schemeClr val="tx1"/>
+                    </a:solidFill>
+                    <a:latin typeface="Arial" charset="0"/>
+                  </a:defRPr>
+                </a:lvl7pPr>
+                <a:lvl8pPr marL="3429000" indent="-228600" eaLnBrk="0" fontAlgn="base" hangingPunct="0">
+                  <a:spcBef>
+                    <a:spcPct val="0"/>
+                  </a:spcBef>
+                  <a:spcAft>
+                    <a:spcPct val="0"/>
+                  </a:spcAft>
+                  <a:defRPr sz="2200">
+                    <a:solidFill>
+                      <a:schemeClr val="tx1"/>
+                    </a:solidFill>
+                    <a:latin typeface="Arial" charset="0"/>
+                  </a:defRPr>
+                </a:lvl8pPr>
+                <a:lvl9pPr marL="3886200" indent="-228600" eaLnBrk="0" fontAlgn="base" hangingPunct="0">
+                  <a:spcBef>
+                    <a:spcPct val="0"/>
+                  </a:spcBef>
+                  <a:spcAft>
+                    <a:spcPct val="0"/>
+                  </a:spcAft>
+                  <a:defRPr sz="2200">
+                    <a:solidFill>
+                      <a:schemeClr val="tx1"/>
+                    </a:solidFill>
+                    <a:latin typeface="Arial" charset="0"/>
+                  </a:defRPr>
+                </a:lvl9pPr>
+              </a:lstStyle>
+              <a:p>
+                <a:pPr eaLnBrk="1" hangingPunct="1"/>
+                <a:r>
+                  <a:rPr lang="" sz="2000" dirty="0">
+                    <a:latin typeface="+mn-lt"/>
+                  </a:rPr>
+                  <a:t>• At 10 pM HER2, diffusion-only transport gives 4.98 pM sensor concentration at 6000 s.</a:t>
+                </a:r>
+                <a:br>
+                  <a:rPr lang="" sz="2000" dirty="0">
+                    <a:latin typeface="+mn-lt"/>
+                  </a:rPr>
+                </a:br>
+                <a:r>
+                  <a:rPr lang="" sz="2000" dirty="0">
+                    <a:latin typeface="+mn-lt"/>
+                  </a:rPr>
+                  <a:t>• Reference flow, </a:t>
+                </a:r>
+                <a14:m>
+                  <m:oMath xmlns:m="http://schemas.openxmlformats.org/officeDocument/2006/math">
+                    <m:sSub>
+                      <m:sSubPr>
+                        <m:ctrlPr>
+                          <a:rPr lang="LID4096" sz="2000" i="1" smtClean="0">
+                            <a:latin typeface="Cambria Math" panose="02040503050406030204" pitchFamily="18" charset="0"/>
+                          </a:rPr>
+                        </m:ctrlPr>
+                      </m:sSubPr>
+                      <m:e>
+                        <m:r>
+                          <a:rPr lang="LID4096" sz="2000" i="1" smtClean="0">
+                            <a:latin typeface="Cambria Math" panose="02040503050406030204" pitchFamily="18" charset="0"/>
+                          </a:rPr>
+                          <m:t>𝑣</m:t>
+                        </m:r>
+                      </m:e>
+                      <m:sub>
+                        <m:r>
+                          <a:rPr lang="LID4096" sz="2000" i="1" smtClean="0">
+                            <a:latin typeface="Cambria Math" panose="02040503050406030204" pitchFamily="18" charset="0"/>
+                          </a:rPr>
+                          <m:t>𝑖𝑛</m:t>
+                        </m:r>
+                      </m:sub>
+                    </m:sSub>
+                  </m:oMath>
+                </a14:m>
+                <a:r>
+                  <a:rPr lang="" sz="2000" dirty="0">
+                    <a:latin typeface="+mn-lt"/>
+                  </a:rPr>
+                  <a:t> = 5 × 10⁻⁷ m/s, gives 8.73 pM at 6000 s.</a:t>
+                </a:r>
+                <a:br>
+                  <a:rPr lang="" sz="2000" dirty="0">
+                    <a:latin typeface="+mn-lt"/>
+                  </a:rPr>
+                </a:br>
+                <a:r>
+                  <a:rPr lang="" sz="2000" dirty="0">
+                    <a:latin typeface="+mn-lt"/>
+                  </a:rPr>
+                  <a:t>• This corresponds to approximately 1.75× higher late-time exposure.</a:t>
+                </a:r>
+                <a:br>
+                  <a:rPr lang="" sz="2000" dirty="0">
+                    <a:latin typeface="+mn-lt"/>
+                  </a:rPr>
+                </a:br>
+                <a:r>
+                  <a:rPr lang="" sz="2000" dirty="0">
+                    <a:latin typeface="+mn-lt"/>
+                  </a:rPr>
+                  <a:t>• Time</a:t>
+                </a:r>
+                <a:r>
+                  <a:rPr lang="tr-TR" sz="2000" dirty="0">
+                    <a:latin typeface="+mn-lt"/>
+                  </a:rPr>
+                  <a:t> </a:t>
+                </a:r>
+                <a:r>
+                  <a:rPr lang="" sz="2000" dirty="0">
+                    <a:latin typeface="+mn-lt"/>
+                  </a:rPr>
+                  <a:t>to</a:t>
+                </a:r>
+                <a:r>
+                  <a:rPr lang="tr-TR" sz="2000" dirty="0">
+                    <a:latin typeface="+mn-lt"/>
+                  </a:rPr>
+                  <a:t> </a:t>
+                </a:r>
+                <a:r>
+                  <a:rPr lang="" sz="2000" dirty="0">
+                    <a:latin typeface="+mn-lt"/>
+                  </a:rPr>
+                  <a:t>50% exposure decreases from 6038 s to 1839 s.</a:t>
+                </a:r>
+                <a:endParaRPr lang="tr-TR" sz="2000" dirty="0">
+                  <a:latin typeface="+mn-lt"/>
+                </a:endParaRPr>
+              </a:p>
+              <a:p>
+                <a:pPr eaLnBrk="1" hangingPunct="1"/>
+                <a:r>
+                  <a:rPr lang="en-US" sz="2000" b="1" i="1" dirty="0">
+                    <a:latin typeface="+mn-lt"/>
+                  </a:rPr>
+                  <a:t>Flow improves exposure, but transport is only the first bottleneck.</a:t>
+                </a:r>
+              </a:p>
+            </p:txBody>
+          </p:sp>
+        </mc:Choice>
+        <mc:Fallback>
+          <p:sp>
+            <p:nvSpPr>
+              <p:cNvPr id="79" name="Text Box 189">
+                <a:extLst>
+                  <a:ext uri="{FF2B5EF4-FFF2-40B4-BE49-F238E27FC236}">
+                    <a16:creationId xmlns:a16="http://schemas.microsoft.com/office/drawing/2014/main" id="{4E3A54A1-9206-0340-2930-030FCADCBC18}"/>
+                  </a:ext>
+                </a:extLst>
+              </p:cNvPr>
+              <p:cNvSpPr txBox="1">
+                <a:spLocks noRot="1" noChangeAspect="1" noMove="1" noResize="1" noEditPoints="1" noAdjustHandles="1" noChangeArrowheads="1" noChangeShapeType="1" noTextEdit="1"/>
+              </p:cNvSpPr>
+              <p:nvPr/>
+            </p:nvSpPr>
+            <p:spPr bwMode="auto">
+              <a:xfrm>
+                <a:off x="22299897" y="10786366"/>
+                <a:ext cx="8787392" cy="2315146"/>
+              </a:xfrm>
+              <a:prstGeom prst="rect">
+                <a:avLst/>
+              </a:prstGeom>
+              <a:blipFill>
+                <a:blip r:embed="rId8"/>
+                <a:stretch>
+                  <a:fillRect/>
+                </a:stretch>
+              </a:blipFill>
+              <a:ln w="12700">
+                <a:solidFill>
+                  <a:schemeClr val="accent1">
+                    <a:lumMod val="75000"/>
+                  </a:schemeClr>
+                </a:solidFill>
+              </a:ln>
+              <a:effectLst/>
+            </p:spPr>
+            <p:txBody>
+              <a:bodyPr/>
+              <a:lstStyle/>
+              <a:p>
+                <a:r>
+                  <a:rPr lang="LID4096">
+                    <a:noFill/>
+                  </a:rPr>
+                  <a:t> </a:t>
+                </a:r>
+              </a:p>
+            </p:txBody>
+          </p:sp>
+        </mc:Fallback>
+      </mc:AlternateContent>
       <p:sp>
         <p:nvSpPr>
           <p:cNvPr id="80" name="Rectangle 79">
@@ -4996,210 +5187,348 @@
           </a:p>
         </p:txBody>
       </p:sp>
-      <p:sp>
-        <p:nvSpPr>
-          <p:cNvPr id="81" name="Text Box 189">
-            <a:extLst>
-              <a:ext uri="{FF2B5EF4-FFF2-40B4-BE49-F238E27FC236}">
-                <a16:creationId xmlns:a16="http://schemas.microsoft.com/office/drawing/2014/main" id="{360361D6-66AE-9A9F-EB72-54D9E94A7EA1}"/>
-              </a:ext>
-            </a:extLst>
-          </p:cNvPr>
-          <p:cNvSpPr txBox="1">
-            <a:spLocks noChangeArrowheads="1"/>
-          </p:cNvSpPr>
-          <p:nvPr/>
-        </p:nvSpPr>
-        <p:spPr bwMode="auto">
-          <a:xfrm>
-            <a:off x="32674793" y="10182034"/>
-            <a:ext cx="8787392" cy="2622923"/>
-          </a:xfrm>
-          <a:prstGeom prst="rect">
-            <a:avLst/>
-          </a:prstGeom>
-          <a:solidFill>
-            <a:schemeClr val="bg1"/>
-          </a:solidFill>
-          <a:ln w="12700">
-            <a:solidFill>
-              <a:schemeClr val="accent1">
-                <a:lumMod val="75000"/>
-              </a:schemeClr>
-            </a:solidFill>
-          </a:ln>
-          <a:effectLst/>
-        </p:spPr>
-        <p:txBody>
-          <a:bodyPr wrap="square" lIns="231978" tIns="231978" rIns="231978" bIns="231978">
-            <a:spAutoFit/>
-          </a:bodyPr>
-          <a:lstStyle>
-            <a:lvl1pPr eaLnBrk="0" hangingPunct="0">
-              <a:defRPr sz="2200">
-                <a:solidFill>
-                  <a:schemeClr val="tx1"/>
-                </a:solidFill>
-                <a:latin typeface="Arial" charset="0"/>
-              </a:defRPr>
-            </a:lvl1pPr>
-            <a:lvl2pPr marL="742950" indent="-285750" eaLnBrk="0" hangingPunct="0">
-              <a:defRPr sz="2200">
-                <a:solidFill>
-                  <a:schemeClr val="tx1"/>
-                </a:solidFill>
-                <a:latin typeface="Arial" charset="0"/>
-              </a:defRPr>
-            </a:lvl2pPr>
-            <a:lvl3pPr marL="1143000" indent="-228600" eaLnBrk="0" hangingPunct="0">
-              <a:defRPr sz="2200">
-                <a:solidFill>
-                  <a:schemeClr val="tx1"/>
-                </a:solidFill>
-                <a:latin typeface="Arial" charset="0"/>
-              </a:defRPr>
-            </a:lvl3pPr>
-            <a:lvl4pPr marL="1600200" indent="-228600" eaLnBrk="0" hangingPunct="0">
-              <a:defRPr sz="2200">
-                <a:solidFill>
-                  <a:schemeClr val="tx1"/>
-                </a:solidFill>
-                <a:latin typeface="Arial" charset="0"/>
-              </a:defRPr>
-            </a:lvl4pPr>
-            <a:lvl5pPr marL="2057400" indent="-228600" eaLnBrk="0" hangingPunct="0">
-              <a:defRPr sz="2200">
-                <a:solidFill>
-                  <a:schemeClr val="tx1"/>
-                </a:solidFill>
-                <a:latin typeface="Arial" charset="0"/>
-              </a:defRPr>
-            </a:lvl5pPr>
-            <a:lvl6pPr marL="2514600" indent="-228600" eaLnBrk="0" fontAlgn="base" hangingPunct="0">
-              <a:spcBef>
-                <a:spcPct val="0"/>
-              </a:spcBef>
-              <a:spcAft>
-                <a:spcPct val="0"/>
-              </a:spcAft>
-              <a:defRPr sz="2200">
-                <a:solidFill>
-                  <a:schemeClr val="tx1"/>
-                </a:solidFill>
-                <a:latin typeface="Arial" charset="0"/>
-              </a:defRPr>
-            </a:lvl6pPr>
-            <a:lvl7pPr marL="2971800" indent="-228600" eaLnBrk="0" fontAlgn="base" hangingPunct="0">
-              <a:spcBef>
-                <a:spcPct val="0"/>
-              </a:spcBef>
-              <a:spcAft>
-                <a:spcPct val="0"/>
-              </a:spcAft>
-              <a:defRPr sz="2200">
-                <a:solidFill>
-                  <a:schemeClr val="tx1"/>
-                </a:solidFill>
-                <a:latin typeface="Arial" charset="0"/>
-              </a:defRPr>
-            </a:lvl7pPr>
-            <a:lvl8pPr marL="3429000" indent="-228600" eaLnBrk="0" fontAlgn="base" hangingPunct="0">
-              <a:spcBef>
-                <a:spcPct val="0"/>
-              </a:spcBef>
-              <a:spcAft>
-                <a:spcPct val="0"/>
-              </a:spcAft>
-              <a:defRPr sz="2200">
-                <a:solidFill>
-                  <a:schemeClr val="tx1"/>
-                </a:solidFill>
-                <a:latin typeface="Arial" charset="0"/>
-              </a:defRPr>
-            </a:lvl8pPr>
-            <a:lvl9pPr marL="3886200" indent="-228600" eaLnBrk="0" fontAlgn="base" hangingPunct="0">
-              <a:spcBef>
-                <a:spcPct val="0"/>
-              </a:spcBef>
-              <a:spcAft>
-                <a:spcPct val="0"/>
-              </a:spcAft>
-              <a:defRPr sz="2200">
-                <a:solidFill>
-                  <a:schemeClr val="tx1"/>
-                </a:solidFill>
-                <a:latin typeface="Arial" charset="0"/>
-              </a:defRPr>
-            </a:lvl9pPr>
-          </a:lstStyle>
-          <a:p>
-            <a:pPr eaLnBrk="1" hangingPunct="1"/>
-            <a:r>
-              <a:rPr lang="" sz="2000" dirty="0">
-                <a:latin typeface="+mn-lt"/>
-              </a:rPr>
-              <a:t>• Detectability was tested across HER2 concentration, Kd, coupling efficiency, and noise floor.</a:t>
-            </a:r>
-            <a:br>
-              <a:rPr lang="" sz="2000" dirty="0">
-                <a:latin typeface="+mn-lt"/>
-              </a:rPr>
-            </a:br>
-            <a:r>
-              <a:rPr lang="" sz="2000" dirty="0">
-                <a:latin typeface="+mn-lt"/>
-              </a:rPr>
-              <a:t>• 99 parameter combinations passed the 3σ detection threshold.</a:t>
-            </a:r>
-            <a:br>
-              <a:rPr lang="" sz="2000" dirty="0">
-                <a:latin typeface="+mn-lt"/>
-              </a:rPr>
-            </a:br>
-            <a:r>
-              <a:rPr lang="" sz="2000" dirty="0">
-                <a:latin typeface="+mn-lt"/>
-              </a:rPr>
-              <a:t>• 36 parameter combinations failed.</a:t>
-            </a:r>
-            <a:br>
-              <a:rPr lang="" sz="2000" dirty="0">
-                <a:latin typeface="+mn-lt"/>
-              </a:rPr>
-            </a:br>
-            <a:r>
-              <a:rPr lang="" sz="2000" dirty="0">
-                <a:latin typeface="+mn-lt"/>
-              </a:rPr>
-              <a:t>• Detection improves with higher concentration, tighter binding, stronger coupling, and lower noise.</a:t>
-            </a:r>
-            <a:endParaRPr lang="tr-TR" sz="2000" dirty="0">
-              <a:latin typeface="+mn-lt"/>
-            </a:endParaRPr>
-          </a:p>
-          <a:p>
-            <a:pPr eaLnBrk="1" hangingPunct="1"/>
-            <a:r>
-              <a:rPr lang="en-US" sz="2000" b="1" i="1" dirty="0">
-                <a:latin typeface="+mn-lt"/>
-              </a:rPr>
-              <a:t>Sub-</a:t>
-            </a:r>
-            <a:r>
-              <a:rPr lang="en-US" sz="2000" b="1" i="1" dirty="0" err="1">
-                <a:latin typeface="+mn-lt"/>
-              </a:rPr>
-              <a:t>pM</a:t>
-            </a:r>
-            <a:r>
-              <a:rPr lang="en-US" sz="2000" b="1" i="1" dirty="0">
-                <a:latin typeface="+mn-lt"/>
-              </a:rPr>
-              <a:t> detection is possible only under favorable assumptions.</a:t>
-            </a:r>
-          </a:p>
-        </p:txBody>
-      </p:sp>
+      <mc:AlternateContent xmlns:mc="http://schemas.openxmlformats.org/markup-compatibility/2006">
+        <mc:Choice xmlns:a14="http://schemas.microsoft.com/office/drawing/2010/main" Requires="a14">
+          <p:sp>
+            <p:nvSpPr>
+              <p:cNvPr id="81" name="Text Box 189">
+                <a:extLst>
+                  <a:ext uri="{FF2B5EF4-FFF2-40B4-BE49-F238E27FC236}">
+                    <a16:creationId xmlns:a16="http://schemas.microsoft.com/office/drawing/2014/main" id="{360361D6-66AE-9A9F-EB72-54D9E94A7EA1}"/>
+                  </a:ext>
+                </a:extLst>
+              </p:cNvPr>
+              <p:cNvSpPr txBox="1">
+                <a:spLocks noChangeArrowheads="1"/>
+              </p:cNvSpPr>
+              <p:nvPr/>
+            </p:nvSpPr>
+            <p:spPr bwMode="auto">
+              <a:xfrm>
+                <a:off x="32674793" y="10182034"/>
+                <a:ext cx="8787392" cy="2622923"/>
+              </a:xfrm>
+              <a:prstGeom prst="rect">
+                <a:avLst/>
+              </a:prstGeom>
+              <a:solidFill>
+                <a:schemeClr val="bg1"/>
+              </a:solidFill>
+              <a:ln w="12700">
+                <a:solidFill>
+                  <a:schemeClr val="accent1">
+                    <a:lumMod val="75000"/>
+                  </a:schemeClr>
+                </a:solidFill>
+              </a:ln>
+              <a:effectLst/>
+            </p:spPr>
+            <p:txBody>
+              <a:bodyPr wrap="square" lIns="231978" tIns="231978" rIns="231978" bIns="231978">
+                <a:spAutoFit/>
+              </a:bodyPr>
+              <a:lstStyle>
+                <a:lvl1pPr eaLnBrk="0" hangingPunct="0">
+                  <a:defRPr sz="2200">
+                    <a:solidFill>
+                      <a:schemeClr val="tx1"/>
+                    </a:solidFill>
+                    <a:latin typeface="Arial" charset="0"/>
+                  </a:defRPr>
+                </a:lvl1pPr>
+                <a:lvl2pPr marL="742950" indent="-285750" eaLnBrk="0" hangingPunct="0">
+                  <a:defRPr sz="2200">
+                    <a:solidFill>
+                      <a:schemeClr val="tx1"/>
+                    </a:solidFill>
+                    <a:latin typeface="Arial" charset="0"/>
+                  </a:defRPr>
+                </a:lvl2pPr>
+                <a:lvl3pPr marL="1143000" indent="-228600" eaLnBrk="0" hangingPunct="0">
+                  <a:defRPr sz="2200">
+                    <a:solidFill>
+                      <a:schemeClr val="tx1"/>
+                    </a:solidFill>
+                    <a:latin typeface="Arial" charset="0"/>
+                  </a:defRPr>
+                </a:lvl3pPr>
+                <a:lvl4pPr marL="1600200" indent="-228600" eaLnBrk="0" hangingPunct="0">
+                  <a:defRPr sz="2200">
+                    <a:solidFill>
+                      <a:schemeClr val="tx1"/>
+                    </a:solidFill>
+                    <a:latin typeface="Arial" charset="0"/>
+                  </a:defRPr>
+                </a:lvl4pPr>
+                <a:lvl5pPr marL="2057400" indent="-228600" eaLnBrk="0" hangingPunct="0">
+                  <a:defRPr sz="2200">
+                    <a:solidFill>
+                      <a:schemeClr val="tx1"/>
+                    </a:solidFill>
+                    <a:latin typeface="Arial" charset="0"/>
+                  </a:defRPr>
+                </a:lvl5pPr>
+                <a:lvl6pPr marL="2514600" indent="-228600" eaLnBrk="0" fontAlgn="base" hangingPunct="0">
+                  <a:spcBef>
+                    <a:spcPct val="0"/>
+                  </a:spcBef>
+                  <a:spcAft>
+                    <a:spcPct val="0"/>
+                  </a:spcAft>
+                  <a:defRPr sz="2200">
+                    <a:solidFill>
+                      <a:schemeClr val="tx1"/>
+                    </a:solidFill>
+                    <a:latin typeface="Arial" charset="0"/>
+                  </a:defRPr>
+                </a:lvl6pPr>
+                <a:lvl7pPr marL="2971800" indent="-228600" eaLnBrk="0" fontAlgn="base" hangingPunct="0">
+                  <a:spcBef>
+                    <a:spcPct val="0"/>
+                  </a:spcBef>
+                  <a:spcAft>
+                    <a:spcPct val="0"/>
+                  </a:spcAft>
+                  <a:defRPr sz="2200">
+                    <a:solidFill>
+                      <a:schemeClr val="tx1"/>
+                    </a:solidFill>
+                    <a:latin typeface="Arial" charset="0"/>
+                  </a:defRPr>
+                </a:lvl7pPr>
+                <a:lvl8pPr marL="3429000" indent="-228600" eaLnBrk="0" fontAlgn="base" hangingPunct="0">
+                  <a:spcBef>
+                    <a:spcPct val="0"/>
+                  </a:spcBef>
+                  <a:spcAft>
+                    <a:spcPct val="0"/>
+                  </a:spcAft>
+                  <a:defRPr sz="2200">
+                    <a:solidFill>
+                      <a:schemeClr val="tx1"/>
+                    </a:solidFill>
+                    <a:latin typeface="Arial" charset="0"/>
+                  </a:defRPr>
+                </a:lvl8pPr>
+                <a:lvl9pPr marL="3886200" indent="-228600" eaLnBrk="0" fontAlgn="base" hangingPunct="0">
+                  <a:spcBef>
+                    <a:spcPct val="0"/>
+                  </a:spcBef>
+                  <a:spcAft>
+                    <a:spcPct val="0"/>
+                  </a:spcAft>
+                  <a:defRPr sz="2200">
+                    <a:solidFill>
+                      <a:schemeClr val="tx1"/>
+                    </a:solidFill>
+                    <a:latin typeface="Arial" charset="0"/>
+                  </a:defRPr>
+                </a:lvl9pPr>
+              </a:lstStyle>
+              <a:p>
+                <a:pPr eaLnBrk="1" hangingPunct="1"/>
+                <a:r>
+                  <a:rPr lang="" sz="2000" dirty="0">
+                    <a:latin typeface="+mn-lt"/>
+                  </a:rPr>
+                  <a:t>• Detectability was tested across HER2 concentration, </a:t>
+                </a:r>
+                <a14:m>
+                  <m:oMath xmlns:m="http://schemas.openxmlformats.org/officeDocument/2006/math">
+                    <m:sSub>
+                      <m:sSubPr>
+                        <m:ctrlPr>
+                          <a:rPr lang="LID4096" sz="2000" i="1" smtClean="0">
+                            <a:latin typeface="Cambria Math" panose="02040503050406030204" pitchFamily="18" charset="0"/>
+                          </a:rPr>
+                        </m:ctrlPr>
+                      </m:sSubPr>
+                      <m:e>
+                        <m:r>
+                          <a:rPr lang="LID4096" sz="2000" i="1">
+                            <a:latin typeface="Cambria Math" panose="02040503050406030204" pitchFamily="18" charset="0"/>
+                          </a:rPr>
+                          <m:t>𝐾</m:t>
+                        </m:r>
+                      </m:e>
+                      <m:sub>
+                        <m:r>
+                          <a:rPr lang="LID4096" sz="2000" i="1">
+                            <a:latin typeface="Cambria Math" panose="02040503050406030204" pitchFamily="18" charset="0"/>
+                          </a:rPr>
+                          <m:t>𝐷</m:t>
+                        </m:r>
+                      </m:sub>
+                    </m:sSub>
+                  </m:oMath>
+                </a14:m>
+                <a:r>
+                  <a:rPr lang="" sz="2000" dirty="0">
+                    <a:latin typeface="+mn-lt"/>
+                  </a:rPr>
+                  <a:t>, coupling efficiency, and noise floor.</a:t>
+                </a:r>
+                <a:br>
+                  <a:rPr lang="" sz="2000" dirty="0">
+                    <a:latin typeface="+mn-lt"/>
+                  </a:rPr>
+                </a:br>
+                <a:r>
+                  <a:rPr lang="" sz="2000" dirty="0">
+                    <a:latin typeface="+mn-lt"/>
+                  </a:rPr>
+                  <a:t>• 99 parameter combinations passed the 3σ detection threshold.</a:t>
+                </a:r>
+                <a:br>
+                  <a:rPr lang="" sz="2000" dirty="0">
+                    <a:latin typeface="+mn-lt"/>
+                  </a:rPr>
+                </a:br>
+                <a:r>
+                  <a:rPr lang="" sz="2000" dirty="0">
+                    <a:latin typeface="+mn-lt"/>
+                  </a:rPr>
+                  <a:t>• 36 parameter combinations failed.</a:t>
+                </a:r>
+                <a:br>
+                  <a:rPr lang="" sz="2000" dirty="0">
+                    <a:latin typeface="+mn-lt"/>
+                  </a:rPr>
+                </a:br>
+                <a:r>
+                  <a:rPr lang="" sz="2000" dirty="0">
+                    <a:latin typeface="+mn-lt"/>
+                  </a:rPr>
+                  <a:t>• Detection</a:t>
+                </a:r>
+                <a:r>
+                  <a:rPr lang="tr-TR" sz="2000" dirty="0">
+                    <a:latin typeface="+mn-lt"/>
+                  </a:rPr>
+                  <a:t> </a:t>
+                </a:r>
+                <a14:m>
+                  <m:oMath xmlns:m="http://schemas.openxmlformats.org/officeDocument/2006/math">
+                    <m:sSub>
+                      <m:sSubPr>
+                        <m:ctrlPr>
+                          <a:rPr lang="LID4096" sz="2000" i="1" smtClean="0">
+                            <a:latin typeface="Cambria Math" panose="02040503050406030204" pitchFamily="18" charset="0"/>
+                          </a:rPr>
+                        </m:ctrlPr>
+                      </m:sSubPr>
+                      <m:e>
+                        <m:r>
+                          <a:rPr lang="LID4096" sz="2000" i="1" smtClean="0">
+                            <a:latin typeface="Cambria Math" panose="02040503050406030204" pitchFamily="18" charset="0"/>
+                          </a:rPr>
+                          <m:t>𝐾</m:t>
+                        </m:r>
+                      </m:e>
+                      <m:sub>
+                        <m:r>
+                          <a:rPr lang="LID4096" sz="2000" i="1" smtClean="0">
+                            <a:latin typeface="Cambria Math" panose="02040503050406030204" pitchFamily="18" charset="0"/>
+                          </a:rPr>
+                          <m:t>𝐷</m:t>
+                        </m:r>
+                      </m:sub>
+                    </m:sSub>
+                  </m:oMath>
+                </a14:m>
+                <a:r>
+                  <a:rPr lang="tr-TR" sz="2000" dirty="0">
+                    <a:latin typeface="+mn-lt"/>
+                  </a:rPr>
+                  <a:t> i</a:t>
+                </a:r>
+                <a:r>
+                  <a:rPr lang="" sz="2000" dirty="0">
+                    <a:latin typeface="+mn-lt"/>
+                  </a:rPr>
+                  <a:t>mproves with higher concentration, tighter binding, stronger coupling, and lower noise.</a:t>
+                </a:r>
+                <a:endParaRPr lang="tr-TR" sz="2000" dirty="0">
+                  <a:latin typeface="+mn-lt"/>
+                </a:endParaRPr>
+              </a:p>
+              <a:p>
+                <a:pPr eaLnBrk="1" hangingPunct="1"/>
+                <a:r>
+                  <a:rPr lang="en-US" sz="2000" b="1" i="1" dirty="0">
+                    <a:latin typeface="+mn-lt"/>
+                  </a:rPr>
+                  <a:t>Sub-</a:t>
+                </a:r>
+                <a:r>
+                  <a:rPr lang="en-US" sz="2000" b="1" i="1" dirty="0" err="1">
+                    <a:latin typeface="+mn-lt"/>
+                  </a:rPr>
+                  <a:t>pM</a:t>
+                </a:r>
+                <a:r>
+                  <a:rPr lang="en-US" sz="2000" b="1" i="1" dirty="0">
+                    <a:latin typeface="+mn-lt"/>
+                  </a:rPr>
+                  <a:t> detection is possible only under favorable assumptions.</a:t>
+                </a:r>
+              </a:p>
+            </p:txBody>
+          </p:sp>
+        </mc:Choice>
+        <mc:Fallback>
+          <p:sp>
+            <p:nvSpPr>
+              <p:cNvPr id="81" name="Text Box 189">
+                <a:extLst>
+                  <a:ext uri="{FF2B5EF4-FFF2-40B4-BE49-F238E27FC236}">
+                    <a16:creationId xmlns:a16="http://schemas.microsoft.com/office/drawing/2014/main" id="{360361D6-66AE-9A9F-EB72-54D9E94A7EA1}"/>
+                  </a:ext>
+                </a:extLst>
+              </p:cNvPr>
+              <p:cNvSpPr txBox="1">
+                <a:spLocks noRot="1" noChangeAspect="1" noMove="1" noResize="1" noEditPoints="1" noAdjustHandles="1" noChangeArrowheads="1" noChangeShapeType="1" noTextEdit="1"/>
+              </p:cNvSpPr>
+              <p:nvPr/>
+            </p:nvSpPr>
+            <p:spPr bwMode="auto">
+              <a:xfrm>
+                <a:off x="32674793" y="10182034"/>
+                <a:ext cx="8787392" cy="2622923"/>
+              </a:xfrm>
+              <a:prstGeom prst="rect">
+                <a:avLst/>
+              </a:prstGeom>
+              <a:blipFill>
+                <a:blip r:embed="rId9"/>
+                <a:stretch>
+                  <a:fillRect/>
+                </a:stretch>
+              </a:blipFill>
+              <a:ln w="12700">
+                <a:solidFill>
+                  <a:schemeClr val="accent1">
+                    <a:lumMod val="75000"/>
+                  </a:schemeClr>
+                </a:solidFill>
+              </a:ln>
+              <a:effectLst/>
+            </p:spPr>
+            <p:txBody>
+              <a:bodyPr/>
+              <a:lstStyle/>
+              <a:p>
+                <a:r>
+                  <a:rPr lang="LID4096">
+                    <a:noFill/>
+                  </a:rPr>
+                  <a:t> </a:t>
+                </a:r>
+              </a:p>
+            </p:txBody>
+          </p:sp>
+        </mc:Fallback>
+      </mc:AlternateContent>
       <p:sp>
         <p:nvSpPr>
           <p:cNvPr id="82" name="Rectangle 81">
@@ -5281,220 +5610,381 @@
           </a:p>
         </p:txBody>
       </p:sp>
-      <p:sp>
-        <p:nvSpPr>
-          <p:cNvPr id="83" name="Text Box 189">
-            <a:extLst>
-              <a:ext uri="{FF2B5EF4-FFF2-40B4-BE49-F238E27FC236}">
-                <a16:creationId xmlns:a16="http://schemas.microsoft.com/office/drawing/2014/main" id="{B255C537-9EC4-3705-CB04-FA63969ECDCD}"/>
-              </a:ext>
-            </a:extLst>
-          </p:cNvPr>
-          <p:cNvSpPr txBox="1">
-            <a:spLocks noChangeArrowheads="1"/>
-          </p:cNvSpPr>
-          <p:nvPr/>
-        </p:nvSpPr>
-        <p:spPr bwMode="auto">
-          <a:xfrm>
-            <a:off x="32521614" y="27010543"/>
-            <a:ext cx="9758288" cy="3238476"/>
-          </a:xfrm>
-          <a:prstGeom prst="rect">
-            <a:avLst/>
-          </a:prstGeom>
-          <a:solidFill>
-            <a:schemeClr val="bg1"/>
-          </a:solidFill>
-          <a:ln w="12700">
-            <a:solidFill>
-              <a:schemeClr val="accent1">
-                <a:lumMod val="75000"/>
-              </a:schemeClr>
-            </a:solidFill>
-          </a:ln>
-          <a:effectLst/>
-        </p:spPr>
-        <p:txBody>
-          <a:bodyPr wrap="square" lIns="231978" tIns="231978" rIns="231978" bIns="231978">
-            <a:spAutoFit/>
-          </a:bodyPr>
-          <a:lstStyle>
-            <a:lvl1pPr eaLnBrk="0" hangingPunct="0">
-              <a:defRPr sz="2200">
-                <a:solidFill>
-                  <a:schemeClr val="tx1"/>
-                </a:solidFill>
-                <a:latin typeface="Arial" charset="0"/>
-              </a:defRPr>
-            </a:lvl1pPr>
-            <a:lvl2pPr marL="742950" indent="-285750" eaLnBrk="0" hangingPunct="0">
-              <a:defRPr sz="2200">
-                <a:solidFill>
-                  <a:schemeClr val="tx1"/>
-                </a:solidFill>
-                <a:latin typeface="Arial" charset="0"/>
-              </a:defRPr>
-            </a:lvl2pPr>
-            <a:lvl3pPr marL="1143000" indent="-228600" eaLnBrk="0" hangingPunct="0">
-              <a:defRPr sz="2200">
-                <a:solidFill>
-                  <a:schemeClr val="tx1"/>
-                </a:solidFill>
-                <a:latin typeface="Arial" charset="0"/>
-              </a:defRPr>
-            </a:lvl3pPr>
-            <a:lvl4pPr marL="1600200" indent="-228600" eaLnBrk="0" hangingPunct="0">
-              <a:defRPr sz="2200">
-                <a:solidFill>
-                  <a:schemeClr val="tx1"/>
-                </a:solidFill>
-                <a:latin typeface="Arial" charset="0"/>
-              </a:defRPr>
-            </a:lvl4pPr>
-            <a:lvl5pPr marL="2057400" indent="-228600" eaLnBrk="0" hangingPunct="0">
-              <a:defRPr sz="2200">
-                <a:solidFill>
-                  <a:schemeClr val="tx1"/>
-                </a:solidFill>
-                <a:latin typeface="Arial" charset="0"/>
-              </a:defRPr>
-            </a:lvl5pPr>
-            <a:lvl6pPr marL="2514600" indent="-228600" eaLnBrk="0" fontAlgn="base" hangingPunct="0">
-              <a:spcBef>
-                <a:spcPct val="0"/>
-              </a:spcBef>
-              <a:spcAft>
-                <a:spcPct val="0"/>
-              </a:spcAft>
-              <a:defRPr sz="2200">
-                <a:solidFill>
-                  <a:schemeClr val="tx1"/>
-                </a:solidFill>
-                <a:latin typeface="Arial" charset="0"/>
-              </a:defRPr>
-            </a:lvl6pPr>
-            <a:lvl7pPr marL="2971800" indent="-228600" eaLnBrk="0" fontAlgn="base" hangingPunct="0">
-              <a:spcBef>
-                <a:spcPct val="0"/>
-              </a:spcBef>
-              <a:spcAft>
-                <a:spcPct val="0"/>
-              </a:spcAft>
-              <a:defRPr sz="2200">
-                <a:solidFill>
-                  <a:schemeClr val="tx1"/>
-                </a:solidFill>
-                <a:latin typeface="Arial" charset="0"/>
-              </a:defRPr>
-            </a:lvl7pPr>
-            <a:lvl8pPr marL="3429000" indent="-228600" eaLnBrk="0" fontAlgn="base" hangingPunct="0">
-              <a:spcBef>
-                <a:spcPct val="0"/>
-              </a:spcBef>
-              <a:spcAft>
-                <a:spcPct val="0"/>
-              </a:spcAft>
-              <a:defRPr sz="2200">
-                <a:solidFill>
-                  <a:schemeClr val="tx1"/>
-                </a:solidFill>
-                <a:latin typeface="Arial" charset="0"/>
-              </a:defRPr>
-            </a:lvl8pPr>
-            <a:lvl9pPr marL="3886200" indent="-228600" eaLnBrk="0" fontAlgn="base" hangingPunct="0">
-              <a:spcBef>
-                <a:spcPct val="0"/>
-              </a:spcBef>
-              <a:spcAft>
-                <a:spcPct val="0"/>
-              </a:spcAft>
-              <a:defRPr sz="2200">
-                <a:solidFill>
-                  <a:schemeClr val="tx1"/>
-                </a:solidFill>
-                <a:latin typeface="Arial" charset="0"/>
-              </a:defRPr>
-            </a:lvl9pPr>
-          </a:lstStyle>
-          <a:p>
-            <a:pPr eaLnBrk="1" hangingPunct="1"/>
-            <a:r>
-              <a:rPr lang="" sz="2000" dirty="0">
-                <a:latin typeface="+mn-lt"/>
-              </a:rPr>
-              <a:t>• Experiment E converts screening failure into design requirements.</a:t>
-            </a:r>
-            <a:br>
-              <a:rPr lang="" sz="2000" dirty="0">
-                <a:latin typeface="+mn-lt"/>
-              </a:rPr>
-            </a:br>
-            <a:r>
-              <a:rPr lang="" sz="2000" dirty="0">
-                <a:latin typeface="+mn-lt"/>
-              </a:rPr>
-              <a:t>• Under PBS-like screening, detection is not robust beyond approximately 1 nm effective receptor-channel distance for the baseline case.</a:t>
-            </a:r>
-            <a:br>
-              <a:rPr lang="" sz="2000" dirty="0">
-                <a:latin typeface="+mn-lt"/>
-              </a:rPr>
-            </a:br>
-            <a:r>
-              <a:rPr lang="" sz="2000" dirty="0">
-                <a:latin typeface="+mn-lt"/>
-              </a:rPr>
-              <a:t>• For Kd = 10 pM, 10 pA noise, PBS-like screening, d = 1 nm:</a:t>
-            </a:r>
-            <a:br>
-              <a:rPr lang="" sz="2000" dirty="0">
-                <a:latin typeface="+mn-lt"/>
-              </a:rPr>
-            </a:br>
-            <a:r>
-              <a:rPr lang="" sz="2000" dirty="0">
-                <a:latin typeface="+mn-lt"/>
-              </a:rPr>
-              <a:t>required α0 ≈ 0.0326 at 1 pM HER2</a:t>
-            </a:r>
-            <a:br>
-              <a:rPr lang="" sz="2000" dirty="0">
-                <a:latin typeface="+mn-lt"/>
-              </a:rPr>
-            </a:br>
-            <a:r>
-              <a:rPr lang="" sz="2000" dirty="0">
-                <a:latin typeface="+mn-lt"/>
-              </a:rPr>
-              <a:t>required α0 ≈ 0.00561 at 10 pM HER2</a:t>
-            </a:r>
-            <a:br>
-              <a:rPr lang="" sz="2000" dirty="0">
-                <a:latin typeface="+mn-lt"/>
-              </a:rPr>
-            </a:br>
-            <a:r>
-              <a:rPr lang="" sz="2000" dirty="0">
-                <a:latin typeface="+mn-lt"/>
-              </a:rPr>
-              <a:t>• Feasible detection requires short receptor distance, strong coupling, low noise, and screening control</a:t>
-            </a:r>
-            <a:endParaRPr lang="tr-TR" sz="2000" dirty="0">
-              <a:latin typeface="+mn-lt"/>
-            </a:endParaRPr>
-          </a:p>
-          <a:p>
-            <a:pPr eaLnBrk="1" hangingPunct="1"/>
-            <a:r>
-              <a:rPr lang="en-US" sz="2000" b="1" i="1" dirty="0">
-                <a:latin typeface="+mn-lt"/>
-              </a:rPr>
-              <a:t>The output is not proof of clinical feasibility; it is a design requirement map.</a:t>
-            </a:r>
-          </a:p>
-        </p:txBody>
-      </p:sp>
+      <mc:AlternateContent xmlns:mc="http://schemas.openxmlformats.org/markup-compatibility/2006">
+        <mc:Choice xmlns:a14="http://schemas.microsoft.com/office/drawing/2010/main" Requires="a14">
+          <p:sp>
+            <p:nvSpPr>
+              <p:cNvPr id="83" name="Text Box 189">
+                <a:extLst>
+                  <a:ext uri="{FF2B5EF4-FFF2-40B4-BE49-F238E27FC236}">
+                    <a16:creationId xmlns:a16="http://schemas.microsoft.com/office/drawing/2014/main" id="{B255C537-9EC4-3705-CB04-FA63969ECDCD}"/>
+                  </a:ext>
+                </a:extLst>
+              </p:cNvPr>
+              <p:cNvSpPr txBox="1">
+                <a:spLocks noChangeArrowheads="1"/>
+              </p:cNvSpPr>
+              <p:nvPr/>
+            </p:nvSpPr>
+            <p:spPr bwMode="auto">
+              <a:xfrm>
+                <a:off x="32521614" y="27010543"/>
+                <a:ext cx="9758288" cy="3238476"/>
+              </a:xfrm>
+              <a:prstGeom prst="rect">
+                <a:avLst/>
+              </a:prstGeom>
+              <a:solidFill>
+                <a:schemeClr val="bg1"/>
+              </a:solidFill>
+              <a:ln w="12700">
+                <a:solidFill>
+                  <a:schemeClr val="accent1">
+                    <a:lumMod val="75000"/>
+                  </a:schemeClr>
+                </a:solidFill>
+              </a:ln>
+              <a:effectLst/>
+            </p:spPr>
+            <p:txBody>
+              <a:bodyPr wrap="square" lIns="231978" tIns="231978" rIns="231978" bIns="231978">
+                <a:spAutoFit/>
+              </a:bodyPr>
+              <a:lstStyle>
+                <a:lvl1pPr eaLnBrk="0" hangingPunct="0">
+                  <a:defRPr sz="2200">
+                    <a:solidFill>
+                      <a:schemeClr val="tx1"/>
+                    </a:solidFill>
+                    <a:latin typeface="Arial" charset="0"/>
+                  </a:defRPr>
+                </a:lvl1pPr>
+                <a:lvl2pPr marL="742950" indent="-285750" eaLnBrk="0" hangingPunct="0">
+                  <a:defRPr sz="2200">
+                    <a:solidFill>
+                      <a:schemeClr val="tx1"/>
+                    </a:solidFill>
+                    <a:latin typeface="Arial" charset="0"/>
+                  </a:defRPr>
+                </a:lvl2pPr>
+                <a:lvl3pPr marL="1143000" indent="-228600" eaLnBrk="0" hangingPunct="0">
+                  <a:defRPr sz="2200">
+                    <a:solidFill>
+                      <a:schemeClr val="tx1"/>
+                    </a:solidFill>
+                    <a:latin typeface="Arial" charset="0"/>
+                  </a:defRPr>
+                </a:lvl3pPr>
+                <a:lvl4pPr marL="1600200" indent="-228600" eaLnBrk="0" hangingPunct="0">
+                  <a:defRPr sz="2200">
+                    <a:solidFill>
+                      <a:schemeClr val="tx1"/>
+                    </a:solidFill>
+                    <a:latin typeface="Arial" charset="0"/>
+                  </a:defRPr>
+                </a:lvl4pPr>
+                <a:lvl5pPr marL="2057400" indent="-228600" eaLnBrk="0" hangingPunct="0">
+                  <a:defRPr sz="2200">
+                    <a:solidFill>
+                      <a:schemeClr val="tx1"/>
+                    </a:solidFill>
+                    <a:latin typeface="Arial" charset="0"/>
+                  </a:defRPr>
+                </a:lvl5pPr>
+                <a:lvl6pPr marL="2514600" indent="-228600" eaLnBrk="0" fontAlgn="base" hangingPunct="0">
+                  <a:spcBef>
+                    <a:spcPct val="0"/>
+                  </a:spcBef>
+                  <a:spcAft>
+                    <a:spcPct val="0"/>
+                  </a:spcAft>
+                  <a:defRPr sz="2200">
+                    <a:solidFill>
+                      <a:schemeClr val="tx1"/>
+                    </a:solidFill>
+                    <a:latin typeface="Arial" charset="0"/>
+                  </a:defRPr>
+                </a:lvl6pPr>
+                <a:lvl7pPr marL="2971800" indent="-228600" eaLnBrk="0" fontAlgn="base" hangingPunct="0">
+                  <a:spcBef>
+                    <a:spcPct val="0"/>
+                  </a:spcBef>
+                  <a:spcAft>
+                    <a:spcPct val="0"/>
+                  </a:spcAft>
+                  <a:defRPr sz="2200">
+                    <a:solidFill>
+                      <a:schemeClr val="tx1"/>
+                    </a:solidFill>
+                    <a:latin typeface="Arial" charset="0"/>
+                  </a:defRPr>
+                </a:lvl7pPr>
+                <a:lvl8pPr marL="3429000" indent="-228600" eaLnBrk="0" fontAlgn="base" hangingPunct="0">
+                  <a:spcBef>
+                    <a:spcPct val="0"/>
+                  </a:spcBef>
+                  <a:spcAft>
+                    <a:spcPct val="0"/>
+                  </a:spcAft>
+                  <a:defRPr sz="2200">
+                    <a:solidFill>
+                      <a:schemeClr val="tx1"/>
+                    </a:solidFill>
+                    <a:latin typeface="Arial" charset="0"/>
+                  </a:defRPr>
+                </a:lvl8pPr>
+                <a:lvl9pPr marL="3886200" indent="-228600" eaLnBrk="0" fontAlgn="base" hangingPunct="0">
+                  <a:spcBef>
+                    <a:spcPct val="0"/>
+                  </a:spcBef>
+                  <a:spcAft>
+                    <a:spcPct val="0"/>
+                  </a:spcAft>
+                  <a:defRPr sz="2200">
+                    <a:solidFill>
+                      <a:schemeClr val="tx1"/>
+                    </a:solidFill>
+                    <a:latin typeface="Arial" charset="0"/>
+                  </a:defRPr>
+                </a:lvl9pPr>
+              </a:lstStyle>
+              <a:p>
+                <a:pPr eaLnBrk="1" hangingPunct="1"/>
+                <a:r>
+                  <a:rPr lang="" sz="2000" dirty="0">
+                    <a:latin typeface="+mn-lt"/>
+                  </a:rPr>
+                  <a:t>• Experiment E converts screening failure into design requirements.</a:t>
+                </a:r>
+                <a:br>
+                  <a:rPr lang="" sz="2000" dirty="0">
+                    <a:latin typeface="+mn-lt"/>
+                  </a:rPr>
+                </a:br>
+                <a:r>
+                  <a:rPr lang="" sz="2000" dirty="0">
+                    <a:latin typeface="+mn-lt"/>
+                  </a:rPr>
+                  <a:t>• Under PBS-like screening, detection is not robust beyond approximately 1 nm effective receptor-channel distance for the baseline case.</a:t>
+                </a:r>
+                <a:br>
+                  <a:rPr lang="" sz="2000" dirty="0">
+                    <a:latin typeface="+mn-lt"/>
+                  </a:rPr>
+                </a:br>
+                <a:r>
+                  <a:rPr lang="" sz="2000" dirty="0">
+                    <a:latin typeface="+mn-lt"/>
+                  </a:rPr>
+                  <a:t>• For </a:t>
+                </a:r>
+                <a14:m>
+                  <m:oMath xmlns:m="http://schemas.openxmlformats.org/officeDocument/2006/math">
+                    <m:sSub>
+                      <m:sSubPr>
+                        <m:ctrlPr>
+                          <a:rPr lang="LID4096" sz="2000" i="1" smtClean="0">
+                            <a:latin typeface="Cambria Math" panose="02040503050406030204" pitchFamily="18" charset="0"/>
+                          </a:rPr>
+                        </m:ctrlPr>
+                      </m:sSubPr>
+                      <m:e>
+                        <m:r>
+                          <a:rPr lang="LID4096" sz="2000" i="1" smtClean="0">
+                            <a:latin typeface="Cambria Math" panose="02040503050406030204" pitchFamily="18" charset="0"/>
+                          </a:rPr>
+                          <m:t>𝐾</m:t>
+                        </m:r>
+                      </m:e>
+                      <m:sub>
+                        <m:r>
+                          <a:rPr lang="LID4096" sz="2000" i="1" smtClean="0">
+                            <a:latin typeface="Cambria Math" panose="02040503050406030204" pitchFamily="18" charset="0"/>
+                          </a:rPr>
+                          <m:t>𝐷</m:t>
+                        </m:r>
+                      </m:sub>
+                    </m:sSub>
+                  </m:oMath>
+                </a14:m>
+                <a:r>
+                  <a:rPr lang="" sz="2000" dirty="0">
+                    <a:latin typeface="+mn-lt"/>
+                  </a:rPr>
+                  <a:t> = 10 pM, 10 pA noise, PBS-like screening, d = 1 nm:</a:t>
+                </a:r>
+                <a:br>
+                  <a:rPr lang="" sz="2000" dirty="0">
+                    <a:latin typeface="+mn-lt"/>
+                  </a:rPr>
+                </a:br>
+                <a:r>
+                  <a:rPr lang="" sz="2000" dirty="0">
+                    <a:latin typeface="+mn-lt"/>
+                  </a:rPr>
+                  <a:t>required </a:t>
+                </a:r>
+                <a14:m>
+                  <m:oMath xmlns:m="http://schemas.openxmlformats.org/officeDocument/2006/math">
+                    <m:sSub>
+                      <m:sSubPr>
+                        <m:ctrlPr>
+                          <a:rPr lang="LID4096" sz="2000" i="1" smtClean="0">
+                            <a:latin typeface="Cambria Math" panose="02040503050406030204" pitchFamily="18" charset="0"/>
+                          </a:rPr>
+                        </m:ctrlPr>
+                      </m:sSubPr>
+                      <m:e>
+                        <m:r>
+                          <a:rPr lang="LID4096" sz="2000" i="1" smtClean="0">
+                            <a:latin typeface="Cambria Math" panose="02040503050406030204" pitchFamily="18" charset="0"/>
+                          </a:rPr>
+                          <m:t>𝛼</m:t>
+                        </m:r>
+                      </m:e>
+                      <m:sub>
+                        <m:r>
+                          <a:rPr lang="LID4096" sz="2000" i="1" smtClean="0">
+                            <a:latin typeface="Cambria Math" panose="02040503050406030204" pitchFamily="18" charset="0"/>
+                          </a:rPr>
+                          <m:t>0</m:t>
+                        </m:r>
+                      </m:sub>
+                    </m:sSub>
+                  </m:oMath>
+                </a14:m>
+                <a:r>
+                  <a:rPr lang="" sz="2000" dirty="0">
+                    <a:latin typeface="+mn-lt"/>
+                  </a:rPr>
+                  <a:t> ≈ 0.0326 at 1 pM HER2</a:t>
+                </a:r>
+                <a:br>
+                  <a:rPr lang="" sz="2000" dirty="0">
+                    <a:latin typeface="+mn-lt"/>
+                  </a:rPr>
+                </a:br>
+                <a:r>
+                  <a:rPr lang="" sz="2000" dirty="0">
+                    <a:latin typeface="+mn-lt"/>
+                  </a:rPr>
+                  <a:t>required </a:t>
+                </a:r>
+                <a14:m>
+                  <m:oMath xmlns:m="http://schemas.openxmlformats.org/officeDocument/2006/math">
+                    <m:sSub>
+                      <m:sSubPr>
+                        <m:ctrlPr>
+                          <a:rPr lang="LID4096" sz="2000" i="1" smtClean="0">
+                            <a:latin typeface="Cambria Math" panose="02040503050406030204" pitchFamily="18" charset="0"/>
+                          </a:rPr>
+                        </m:ctrlPr>
+                      </m:sSubPr>
+                      <m:e>
+                        <m:r>
+                          <a:rPr lang="LID4096" sz="2000" i="1" smtClean="0">
+                            <a:latin typeface="Cambria Math" panose="02040503050406030204" pitchFamily="18" charset="0"/>
+                          </a:rPr>
+                          <m:t>𝛼</m:t>
+                        </m:r>
+                      </m:e>
+                      <m:sub>
+                        <m:r>
+                          <a:rPr lang="LID4096" sz="2000" i="1" smtClean="0">
+                            <a:latin typeface="Cambria Math" panose="02040503050406030204" pitchFamily="18" charset="0"/>
+                          </a:rPr>
+                          <m:t>0</m:t>
+                        </m:r>
+                      </m:sub>
+                    </m:sSub>
+                  </m:oMath>
+                </a14:m>
+                <a:r>
+                  <a:rPr lang="" sz="2000" dirty="0">
+                    <a:latin typeface="+mn-lt"/>
+                  </a:rPr>
+                  <a:t> ≈ 0.00561 at 10 pM HER2</a:t>
+                </a:r>
+                <a:br>
+                  <a:rPr lang="" sz="2000" dirty="0">
+                    <a:latin typeface="+mn-lt"/>
+                  </a:rPr>
+                </a:br>
+                <a:r>
+                  <a:rPr lang="" sz="2000" dirty="0">
+                    <a:latin typeface="+mn-lt"/>
+                  </a:rPr>
+                  <a:t>• Feasible detection requires short receptor distance, strong coupling, low noise, and screening control</a:t>
+                </a:r>
+                <a:endParaRPr lang="tr-TR" sz="2000" dirty="0">
+                  <a:latin typeface="+mn-lt"/>
+                </a:endParaRPr>
+              </a:p>
+              <a:p>
+                <a:pPr eaLnBrk="1" hangingPunct="1"/>
+                <a:r>
+                  <a:rPr lang="en-US" sz="2000" b="1" i="1" dirty="0">
+                    <a:latin typeface="+mn-lt"/>
+                  </a:rPr>
+                  <a:t>The output is not proof of clinical feasibility; it is a design requirement map.</a:t>
+                </a:r>
+              </a:p>
+            </p:txBody>
+          </p:sp>
+        </mc:Choice>
+        <mc:Fallback>
+          <p:sp>
+            <p:nvSpPr>
+              <p:cNvPr id="83" name="Text Box 189">
+                <a:extLst>
+                  <a:ext uri="{FF2B5EF4-FFF2-40B4-BE49-F238E27FC236}">
+                    <a16:creationId xmlns:a16="http://schemas.microsoft.com/office/drawing/2014/main" id="{B255C537-9EC4-3705-CB04-FA63969ECDCD}"/>
+                  </a:ext>
+                </a:extLst>
+              </p:cNvPr>
+              <p:cNvSpPr txBox="1">
+                <a:spLocks noRot="1" noChangeAspect="1" noMove="1" noResize="1" noEditPoints="1" noAdjustHandles="1" noChangeArrowheads="1" noChangeShapeType="1" noTextEdit="1"/>
+              </p:cNvSpPr>
+              <p:nvPr/>
+            </p:nvSpPr>
+            <p:spPr bwMode="auto">
+              <a:xfrm>
+                <a:off x="32521614" y="27010543"/>
+                <a:ext cx="9758288" cy="3238476"/>
+              </a:xfrm>
+              <a:prstGeom prst="rect">
+                <a:avLst/>
+              </a:prstGeom>
+              <a:blipFill>
+                <a:blip r:embed="rId10"/>
+                <a:stretch>
+                  <a:fillRect/>
+                </a:stretch>
+              </a:blipFill>
+              <a:ln w="12700">
+                <a:solidFill>
+                  <a:schemeClr val="accent1">
+                    <a:lumMod val="75000"/>
+                  </a:schemeClr>
+                </a:solidFill>
+              </a:ln>
+              <a:effectLst/>
+            </p:spPr>
+            <p:txBody>
+              <a:bodyPr/>
+              <a:lstStyle/>
+              <a:p>
+                <a:r>
+                  <a:rPr lang="LID4096">
+                    <a:noFill/>
+                  </a:rPr>
+                  <a:t> </a:t>
+                </a:r>
+              </a:p>
+            </p:txBody>
+          </p:sp>
+        </mc:Fallback>
+      </mc:AlternateContent>
       <p:sp>
         <p:nvSpPr>
           <p:cNvPr id="84" name="Rectangle 83">
@@ -5509,7 +5999,7 @@
         </p:nvSpPr>
         <p:spPr>
           <a:xfrm>
-            <a:off x="18392472" y="25243790"/>
+            <a:off x="9209881" y="25651756"/>
             <a:ext cx="12693564" cy="1120774"/>
           </a:xfrm>
           <a:prstGeom prst="rect">
@@ -5572,8 +6062,8 @@
         </p:nvSpPr>
         <p:spPr bwMode="auto">
           <a:xfrm>
-            <a:off x="18392472" y="26364564"/>
-            <a:ext cx="12693564" cy="3854029"/>
+            <a:off x="9209881" y="26772530"/>
+            <a:ext cx="12693564" cy="2930699"/>
           </a:xfrm>
           <a:prstGeom prst="rect">
             <a:avLst/>
@@ -5695,111 +6185,54 @@
           <a:p>
             <a:pPr eaLnBrk="1" hangingPunct="1"/>
             <a:r>
-              <a:rPr lang="" sz="2000" dirty="0">
+              <a:rPr lang="en-US" sz="2000" dirty="0">
                 <a:latin typeface="+mn-lt"/>
               </a:rPr>
-              <a:t>• Directional lymph-node-inspired flow improves HER2 exposure at the sensor.</a:t>
-            </a:r>
-            <a:br>
-              <a:rPr lang="" sz="2000" dirty="0">
+              <a:t>• Directional flow increases HER2 exposure at the sensing region.</a:t>
+            </a:r>
+          </a:p>
+          <a:p>
+            <a:pPr eaLnBrk="1" hangingPunct="1"/>
+            <a:r>
+              <a:rPr lang="en-US" sz="2000" dirty="0">
                 <a:latin typeface="+mn-lt"/>
               </a:rPr>
-            </a:br>
-            <a:r>
-              <a:rPr lang="" sz="2000" dirty="0">
+              <a:t>• Sensor placement affects response timing and current response.</a:t>
+            </a:r>
+          </a:p>
+          <a:p>
+            <a:pPr eaLnBrk="1" hangingPunct="1"/>
+            <a:r>
+              <a:rPr lang="en-US" sz="2000" dirty="0">
                 <a:latin typeface="+mn-lt"/>
               </a:rPr>
-              <a:t>• Sensor placement changes response timing and current response.</a:t>
-            </a:r>
-            <a:br>
-              <a:rPr lang="" sz="2000" dirty="0">
+              <a:t>• Detectability is conditional, not guaranteed.</a:t>
+            </a:r>
+          </a:p>
+          <a:p>
+            <a:pPr eaLnBrk="1" hangingPunct="1"/>
+            <a:r>
+              <a:rPr lang="en-US" sz="2000" dirty="0">
                 <a:latin typeface="+mn-lt"/>
               </a:rPr>
-            </a:br>
-            <a:r>
-              <a:rPr lang="" sz="2000" dirty="0">
+              <a:t>• Under physiological-like screening, receptor-channel distance and electronics noise dominate feasibility.</a:t>
+            </a:r>
+          </a:p>
+          <a:p>
+            <a:pPr eaLnBrk="1" hangingPunct="1"/>
+            <a:r>
+              <a:rPr lang="en-US" sz="2000" dirty="0">
                 <a:latin typeface="+mn-lt"/>
               </a:rPr>
-              <a:t>• Detectability is conditional, not guaranteed.</a:t>
-            </a:r>
-            <a:br>
-              <a:rPr lang="" sz="2000" dirty="0">
-                <a:latin typeface="+mn-lt"/>
-              </a:rPr>
-            </a:br>
-            <a:r>
-              <a:rPr lang="" sz="2000" dirty="0">
-                <a:latin typeface="+mn-lt"/>
-              </a:rPr>
-              <a:t>• Debye screening and receptor-channel distance dominate feasibility under physiological-like conditions.</a:t>
-            </a:r>
-            <a:br>
-              <a:rPr lang="" sz="2000" dirty="0">
-                <a:latin typeface="+mn-lt"/>
-              </a:rPr>
-            </a:br>
-            <a:r>
-              <a:rPr lang="" sz="2000" dirty="0">
-                <a:latin typeface="+mn-lt"/>
-              </a:rPr>
-              <a:t>• A feasible GFET-HER2 design would require:</a:t>
-            </a:r>
-            <a:br>
-              <a:rPr lang="" sz="2000" dirty="0">
-                <a:latin typeface="+mn-lt"/>
-              </a:rPr>
-            </a:br>
-            <a:r>
-              <a:rPr lang="" sz="2000" b="1" i="1" dirty="0">
-                <a:latin typeface="+mn-lt"/>
-              </a:rPr>
-              <a:t>short receptor-channel distance,</a:t>
-            </a:r>
-            <a:br>
-              <a:rPr lang="" sz="2000" b="1" i="1" dirty="0">
-                <a:latin typeface="+mn-lt"/>
-              </a:rPr>
-            </a:br>
-            <a:r>
-              <a:rPr lang="" sz="2000" b="1" i="1" dirty="0">
-                <a:latin typeface="+mn-lt"/>
-              </a:rPr>
-              <a:t>strong transduction coupling,</a:t>
-            </a:r>
-            <a:br>
-              <a:rPr lang="" sz="2000" b="1" i="1" dirty="0">
-                <a:latin typeface="+mn-lt"/>
-              </a:rPr>
-            </a:br>
-            <a:r>
-              <a:rPr lang="" sz="2000" b="1" i="1" dirty="0">
-                <a:latin typeface="+mn-lt"/>
-              </a:rPr>
-              <a:t>low current noise,</a:t>
-            </a:r>
-            <a:br>
-              <a:rPr lang="" sz="2000" b="1" i="1" dirty="0">
-                <a:latin typeface="+mn-lt"/>
-              </a:rPr>
-            </a:br>
-            <a:r>
-              <a:rPr lang="" sz="2000" b="1" i="1" dirty="0">
-                <a:latin typeface="+mn-lt"/>
-              </a:rPr>
-              <a:t>favorable binding affinity,</a:t>
-            </a:r>
-            <a:br>
-              <a:rPr lang="" sz="2000" b="1" i="1" dirty="0">
-                <a:latin typeface="+mn-lt"/>
-              </a:rPr>
-            </a:br>
-            <a:r>
-              <a:rPr lang="" sz="2000" b="1" i="1" dirty="0">
-                <a:latin typeface="+mn-lt"/>
-              </a:rPr>
-              <a:t>and local screening mitigation.</a:t>
-            </a:r>
-            <a:endParaRPr lang="tr-TR" sz="2000" b="1" i="1" dirty="0">
+              <a:t>• A feasible GFET-HER2 design requires short receptor distance, strong coupling, low noise, favorable binding, and screening mitigation.</a:t>
+            </a:r>
+          </a:p>
+          <a:p>
+            <a:pPr eaLnBrk="1" hangingPunct="1"/>
+            <a:endParaRPr lang="en-US" sz="2000" b="1" dirty="0">
+              <a:solidFill>
+                <a:srgbClr val="C00000"/>
+              </a:solidFill>
               <a:latin typeface="+mn-lt"/>
             </a:endParaRPr>
           </a:p>
@@ -5893,214 +6326,365 @@
                   </a:schemeClr>
                 </a:solidFill>
               </a:rPr>
-              <a:t> Physiological Screening Can Kill the Signal</a:t>
+              <a:t> Physiological Screening</a:t>
+            </a:r>
+            <a:r>
+              <a:rPr lang="tr-TR" sz="4000" b="1" dirty="0">
+                <a:solidFill>
+                  <a:schemeClr val="accent3">
+                    <a:lumMod val="20000"/>
+                    <a:lumOff val="80000"/>
+                  </a:schemeClr>
+                </a:solidFill>
+              </a:rPr>
+              <a:t> Suppresses</a:t>
+            </a:r>
+            <a:r>
+              <a:rPr lang="en-US" sz="4000" b="1" dirty="0">
+                <a:solidFill>
+                  <a:schemeClr val="accent3">
+                    <a:lumMod val="20000"/>
+                    <a:lumOff val="80000"/>
+                  </a:schemeClr>
+                </a:solidFill>
+              </a:rPr>
+              <a:t> the Signal</a:t>
             </a:r>
           </a:p>
         </p:txBody>
       </p:sp>
-      <p:sp>
-        <p:nvSpPr>
-          <p:cNvPr id="87" name="Text Box 189">
-            <a:extLst>
-              <a:ext uri="{FF2B5EF4-FFF2-40B4-BE49-F238E27FC236}">
-                <a16:creationId xmlns:a16="http://schemas.microsoft.com/office/drawing/2014/main" id="{9F5256B7-0FC4-6C42-76FC-1AD14E74B292}"/>
-              </a:ext>
-            </a:extLst>
-          </p:cNvPr>
-          <p:cNvSpPr txBox="1">
-            <a:spLocks noChangeArrowheads="1"/>
-          </p:cNvSpPr>
-          <p:nvPr/>
-        </p:nvSpPr>
-        <p:spPr bwMode="auto">
-          <a:xfrm>
-            <a:off x="32736475" y="18875765"/>
-            <a:ext cx="8787392" cy="2622923"/>
-          </a:xfrm>
-          <a:prstGeom prst="rect">
-            <a:avLst/>
-          </a:prstGeom>
-          <a:solidFill>
-            <a:schemeClr val="bg1"/>
-          </a:solidFill>
-          <a:ln w="12700">
-            <a:solidFill>
-              <a:schemeClr val="accent1">
-                <a:lumMod val="75000"/>
-              </a:schemeClr>
-            </a:solidFill>
-          </a:ln>
-          <a:effectLst/>
-        </p:spPr>
-        <p:txBody>
-          <a:bodyPr wrap="square" lIns="231978" tIns="231978" rIns="231978" bIns="231978">
-            <a:spAutoFit/>
-          </a:bodyPr>
-          <a:lstStyle>
-            <a:lvl1pPr eaLnBrk="0" hangingPunct="0">
-              <a:defRPr sz="2200">
-                <a:solidFill>
-                  <a:schemeClr val="tx1"/>
-                </a:solidFill>
-                <a:latin typeface="Arial" charset="0"/>
-              </a:defRPr>
-            </a:lvl1pPr>
-            <a:lvl2pPr marL="742950" indent="-285750" eaLnBrk="0" hangingPunct="0">
-              <a:defRPr sz="2200">
-                <a:solidFill>
-                  <a:schemeClr val="tx1"/>
-                </a:solidFill>
-                <a:latin typeface="Arial" charset="0"/>
-              </a:defRPr>
-            </a:lvl2pPr>
-            <a:lvl3pPr marL="1143000" indent="-228600" eaLnBrk="0" hangingPunct="0">
-              <a:defRPr sz="2200">
-                <a:solidFill>
-                  <a:schemeClr val="tx1"/>
-                </a:solidFill>
-                <a:latin typeface="Arial" charset="0"/>
-              </a:defRPr>
-            </a:lvl3pPr>
-            <a:lvl4pPr marL="1600200" indent="-228600" eaLnBrk="0" hangingPunct="0">
-              <a:defRPr sz="2200">
-                <a:solidFill>
-                  <a:schemeClr val="tx1"/>
-                </a:solidFill>
-                <a:latin typeface="Arial" charset="0"/>
-              </a:defRPr>
-            </a:lvl4pPr>
-            <a:lvl5pPr marL="2057400" indent="-228600" eaLnBrk="0" hangingPunct="0">
-              <a:defRPr sz="2200">
-                <a:solidFill>
-                  <a:schemeClr val="tx1"/>
-                </a:solidFill>
-                <a:latin typeface="Arial" charset="0"/>
-              </a:defRPr>
-            </a:lvl5pPr>
-            <a:lvl6pPr marL="2514600" indent="-228600" eaLnBrk="0" fontAlgn="base" hangingPunct="0">
-              <a:spcBef>
-                <a:spcPct val="0"/>
-              </a:spcBef>
-              <a:spcAft>
-                <a:spcPct val="0"/>
-              </a:spcAft>
-              <a:defRPr sz="2200">
-                <a:solidFill>
-                  <a:schemeClr val="tx1"/>
-                </a:solidFill>
-                <a:latin typeface="Arial" charset="0"/>
-              </a:defRPr>
-            </a:lvl6pPr>
-            <a:lvl7pPr marL="2971800" indent="-228600" eaLnBrk="0" fontAlgn="base" hangingPunct="0">
-              <a:spcBef>
-                <a:spcPct val="0"/>
-              </a:spcBef>
-              <a:spcAft>
-                <a:spcPct val="0"/>
-              </a:spcAft>
-              <a:defRPr sz="2200">
-                <a:solidFill>
-                  <a:schemeClr val="tx1"/>
-                </a:solidFill>
-                <a:latin typeface="Arial" charset="0"/>
-              </a:defRPr>
-            </a:lvl7pPr>
-            <a:lvl8pPr marL="3429000" indent="-228600" eaLnBrk="0" fontAlgn="base" hangingPunct="0">
-              <a:spcBef>
-                <a:spcPct val="0"/>
-              </a:spcBef>
-              <a:spcAft>
-                <a:spcPct val="0"/>
-              </a:spcAft>
-              <a:defRPr sz="2200">
-                <a:solidFill>
-                  <a:schemeClr val="tx1"/>
-                </a:solidFill>
-                <a:latin typeface="Arial" charset="0"/>
-              </a:defRPr>
-            </a:lvl8pPr>
-            <a:lvl9pPr marL="3886200" indent="-228600" eaLnBrk="0" fontAlgn="base" hangingPunct="0">
-              <a:spcBef>
-                <a:spcPct val="0"/>
-              </a:spcBef>
-              <a:spcAft>
-                <a:spcPct val="0"/>
-              </a:spcAft>
-              <a:defRPr sz="2200">
-                <a:solidFill>
-                  <a:schemeClr val="tx1"/>
-                </a:solidFill>
-                <a:latin typeface="Arial" charset="0"/>
-              </a:defRPr>
-            </a:lvl9pPr>
-          </a:lstStyle>
-          <a:p>
-            <a:pPr eaLnBrk="1" hangingPunct="1"/>
-            <a:r>
-              <a:rPr lang="" sz="2000" dirty="0">
-                <a:latin typeface="+mn-lt"/>
-              </a:rPr>
-              <a:t>• Debye screening attenuates effective GFET coupling:</a:t>
-            </a:r>
-            <a:br>
-              <a:rPr lang="" sz="2000" dirty="0">
-                <a:latin typeface="+mn-lt"/>
-              </a:rPr>
-            </a:br>
-            <a:r>
-              <a:rPr lang="" sz="2000" dirty="0">
-                <a:latin typeface="+mn-lt"/>
-              </a:rPr>
-              <a:t>αeff = α0 exp(−d / λD)</a:t>
-            </a:r>
-            <a:br>
-              <a:rPr lang="" sz="2000" dirty="0">
-                <a:latin typeface="+mn-lt"/>
-              </a:rPr>
-            </a:br>
-            <a:r>
-              <a:rPr lang="" sz="2000" dirty="0">
-                <a:latin typeface="+mn-lt"/>
-              </a:rPr>
-              <a:t>• PBS-like screening uses λD ≈ 0.8 nm.</a:t>
-            </a:r>
-            <a:br>
-              <a:rPr lang="" sz="2000" dirty="0">
-                <a:latin typeface="+mn-lt"/>
-              </a:rPr>
-            </a:br>
-            <a:r>
-              <a:rPr lang="" sz="2000" dirty="0">
-                <a:latin typeface="+mn-lt"/>
-              </a:rPr>
-              <a:t>• For PBS-like screening and d ≥ 5 nm, 0/60 screened cases remain detectable.</a:t>
-            </a:r>
-            <a:br>
-              <a:rPr lang="" sz="2000" dirty="0">
-                <a:latin typeface="+mn-lt"/>
-              </a:rPr>
-            </a:br>
-            <a:r>
-              <a:rPr lang="" sz="2000" dirty="0">
-                <a:latin typeface="+mn-lt"/>
-              </a:rPr>
-              <a:t>• Transport improvement alone cannot overcome electrostatic screening.</a:t>
-            </a:r>
-            <a:endParaRPr lang="tr-TR" sz="2000" dirty="0">
-              <a:latin typeface="+mn-lt"/>
-            </a:endParaRPr>
-          </a:p>
-          <a:p>
-            <a:pPr eaLnBrk="1" hangingPunct="1"/>
-            <a:r>
-              <a:rPr lang="en-US" sz="2000" b="1" i="1" dirty="0">
-                <a:latin typeface="+mn-lt"/>
-              </a:rPr>
-              <a:t>Main negative result: even if HER2 reaches the sensor, the signal can be screened out.</a:t>
-            </a:r>
-          </a:p>
-        </p:txBody>
-      </p:sp>
+      <mc:AlternateContent xmlns:mc="http://schemas.openxmlformats.org/markup-compatibility/2006">
+        <mc:Choice xmlns:a14="http://schemas.microsoft.com/office/drawing/2010/main" Requires="a14">
+          <p:sp>
+            <p:nvSpPr>
+              <p:cNvPr id="87" name="Text Box 189">
+                <a:extLst>
+                  <a:ext uri="{FF2B5EF4-FFF2-40B4-BE49-F238E27FC236}">
+                    <a16:creationId xmlns:a16="http://schemas.microsoft.com/office/drawing/2014/main" id="{9F5256B7-0FC4-6C42-76FC-1AD14E74B292}"/>
+                  </a:ext>
+                </a:extLst>
+              </p:cNvPr>
+              <p:cNvSpPr txBox="1">
+                <a:spLocks noChangeArrowheads="1"/>
+              </p:cNvSpPr>
+              <p:nvPr/>
+            </p:nvSpPr>
+            <p:spPr bwMode="auto">
+              <a:xfrm>
+                <a:off x="32736475" y="18875765"/>
+                <a:ext cx="8787392" cy="2622923"/>
+              </a:xfrm>
+              <a:prstGeom prst="rect">
+                <a:avLst/>
+              </a:prstGeom>
+              <a:solidFill>
+                <a:schemeClr val="bg1"/>
+              </a:solidFill>
+              <a:ln w="12700">
+                <a:solidFill>
+                  <a:schemeClr val="accent1">
+                    <a:lumMod val="75000"/>
+                  </a:schemeClr>
+                </a:solidFill>
+              </a:ln>
+              <a:effectLst/>
+            </p:spPr>
+            <p:txBody>
+              <a:bodyPr wrap="square" lIns="231978" tIns="231978" rIns="231978" bIns="231978">
+                <a:spAutoFit/>
+              </a:bodyPr>
+              <a:lstStyle>
+                <a:lvl1pPr eaLnBrk="0" hangingPunct="0">
+                  <a:defRPr sz="2200">
+                    <a:solidFill>
+                      <a:schemeClr val="tx1"/>
+                    </a:solidFill>
+                    <a:latin typeface="Arial" charset="0"/>
+                  </a:defRPr>
+                </a:lvl1pPr>
+                <a:lvl2pPr marL="742950" indent="-285750" eaLnBrk="0" hangingPunct="0">
+                  <a:defRPr sz="2200">
+                    <a:solidFill>
+                      <a:schemeClr val="tx1"/>
+                    </a:solidFill>
+                    <a:latin typeface="Arial" charset="0"/>
+                  </a:defRPr>
+                </a:lvl2pPr>
+                <a:lvl3pPr marL="1143000" indent="-228600" eaLnBrk="0" hangingPunct="0">
+                  <a:defRPr sz="2200">
+                    <a:solidFill>
+                      <a:schemeClr val="tx1"/>
+                    </a:solidFill>
+                    <a:latin typeface="Arial" charset="0"/>
+                  </a:defRPr>
+                </a:lvl3pPr>
+                <a:lvl4pPr marL="1600200" indent="-228600" eaLnBrk="0" hangingPunct="0">
+                  <a:defRPr sz="2200">
+                    <a:solidFill>
+                      <a:schemeClr val="tx1"/>
+                    </a:solidFill>
+                    <a:latin typeface="Arial" charset="0"/>
+                  </a:defRPr>
+                </a:lvl4pPr>
+                <a:lvl5pPr marL="2057400" indent="-228600" eaLnBrk="0" hangingPunct="0">
+                  <a:defRPr sz="2200">
+                    <a:solidFill>
+                      <a:schemeClr val="tx1"/>
+                    </a:solidFill>
+                    <a:latin typeface="Arial" charset="0"/>
+                  </a:defRPr>
+                </a:lvl5pPr>
+                <a:lvl6pPr marL="2514600" indent="-228600" eaLnBrk="0" fontAlgn="base" hangingPunct="0">
+                  <a:spcBef>
+                    <a:spcPct val="0"/>
+                  </a:spcBef>
+                  <a:spcAft>
+                    <a:spcPct val="0"/>
+                  </a:spcAft>
+                  <a:defRPr sz="2200">
+                    <a:solidFill>
+                      <a:schemeClr val="tx1"/>
+                    </a:solidFill>
+                    <a:latin typeface="Arial" charset="0"/>
+                  </a:defRPr>
+                </a:lvl6pPr>
+                <a:lvl7pPr marL="2971800" indent="-228600" eaLnBrk="0" fontAlgn="base" hangingPunct="0">
+                  <a:spcBef>
+                    <a:spcPct val="0"/>
+                  </a:spcBef>
+                  <a:spcAft>
+                    <a:spcPct val="0"/>
+                  </a:spcAft>
+                  <a:defRPr sz="2200">
+                    <a:solidFill>
+                      <a:schemeClr val="tx1"/>
+                    </a:solidFill>
+                    <a:latin typeface="Arial" charset="0"/>
+                  </a:defRPr>
+                </a:lvl7pPr>
+                <a:lvl8pPr marL="3429000" indent="-228600" eaLnBrk="0" fontAlgn="base" hangingPunct="0">
+                  <a:spcBef>
+                    <a:spcPct val="0"/>
+                  </a:spcBef>
+                  <a:spcAft>
+                    <a:spcPct val="0"/>
+                  </a:spcAft>
+                  <a:defRPr sz="2200">
+                    <a:solidFill>
+                      <a:schemeClr val="tx1"/>
+                    </a:solidFill>
+                    <a:latin typeface="Arial" charset="0"/>
+                  </a:defRPr>
+                </a:lvl8pPr>
+                <a:lvl9pPr marL="3886200" indent="-228600" eaLnBrk="0" fontAlgn="base" hangingPunct="0">
+                  <a:spcBef>
+                    <a:spcPct val="0"/>
+                  </a:spcBef>
+                  <a:spcAft>
+                    <a:spcPct val="0"/>
+                  </a:spcAft>
+                  <a:defRPr sz="2200">
+                    <a:solidFill>
+                      <a:schemeClr val="tx1"/>
+                    </a:solidFill>
+                    <a:latin typeface="Arial" charset="0"/>
+                  </a:defRPr>
+                </a:lvl9pPr>
+              </a:lstStyle>
+              <a:p>
+                <a:pPr eaLnBrk="1" hangingPunct="1"/>
+                <a:r>
+                  <a:rPr lang="" sz="2000" dirty="0">
+                    <a:latin typeface="+mn-lt"/>
+                  </a:rPr>
+                  <a:t>• Debye screening attenuates effective GFET coupling:</a:t>
+                </a:r>
+                <a:br>
+                  <a:rPr lang="" sz="2000" dirty="0">
+                    <a:latin typeface="+mn-lt"/>
+                  </a:rPr>
+                </a:br>
+                <a14:m>
+                  <m:oMath xmlns:m="http://schemas.openxmlformats.org/officeDocument/2006/math">
+                    <m:sSub>
+                      <m:sSubPr>
+                        <m:ctrlPr>
+                          <a:rPr lang="LID4096" sz="2000" i="1" smtClean="0">
+                            <a:latin typeface="Cambria Math" panose="02040503050406030204" pitchFamily="18" charset="0"/>
+                          </a:rPr>
+                        </m:ctrlPr>
+                      </m:sSubPr>
+                      <m:e>
+                        <m:r>
+                          <a:rPr lang="LID4096" sz="2000" i="1" smtClean="0">
+                            <a:latin typeface="Cambria Math" panose="02040503050406030204" pitchFamily="18" charset="0"/>
+                          </a:rPr>
+                          <m:t>𝛼</m:t>
+                        </m:r>
+                      </m:e>
+                      <m:sub>
+                        <m:r>
+                          <m:rPr>
+                            <m:nor/>
+                          </m:rPr>
+                          <a:rPr lang="LID4096" sz="2000" i="0" smtClean="0">
+                            <a:latin typeface="Cambria Math" panose="02040503050406030204" pitchFamily="18" charset="0"/>
+                          </a:rPr>
+                          <m:t>eff</m:t>
+                        </m:r>
+                      </m:sub>
+                    </m:sSub>
+                  </m:oMath>
+                </a14:m>
+                <a:r>
+                  <a:rPr lang="tr-TR" sz="2000" dirty="0">
+                    <a:latin typeface="+mn-lt"/>
+                  </a:rPr>
+                  <a:t> </a:t>
+                </a:r>
+                <a:r>
+                  <a:rPr lang="" sz="2000" dirty="0">
+                    <a:latin typeface="+mn-lt"/>
+                  </a:rPr>
+                  <a:t>= </a:t>
+                </a:r>
+                <a14:m>
+                  <m:oMath xmlns:m="http://schemas.openxmlformats.org/officeDocument/2006/math">
+                    <m:sSub>
+                      <m:sSubPr>
+                        <m:ctrlPr>
+                          <a:rPr lang="LID4096" sz="2000" i="1" smtClean="0">
+                            <a:latin typeface="Cambria Math" panose="02040503050406030204" pitchFamily="18" charset="0"/>
+                          </a:rPr>
+                        </m:ctrlPr>
+                      </m:sSubPr>
+                      <m:e>
+                        <m:r>
+                          <a:rPr lang="LID4096" sz="2000" i="1" smtClean="0">
+                            <a:latin typeface="Cambria Math" panose="02040503050406030204" pitchFamily="18" charset="0"/>
+                          </a:rPr>
+                          <m:t>𝛼</m:t>
+                        </m:r>
+                      </m:e>
+                      <m:sub>
+                        <m:r>
+                          <a:rPr lang="LID4096" sz="2000" i="1" smtClean="0">
+                            <a:latin typeface="Cambria Math" panose="02040503050406030204" pitchFamily="18" charset="0"/>
+                          </a:rPr>
+                          <m:t>0</m:t>
+                        </m:r>
+                      </m:sub>
+                    </m:sSub>
+                  </m:oMath>
+                </a14:m>
+                <a:r>
+                  <a:rPr lang="" sz="2000" dirty="0">
+                    <a:latin typeface="+mn-lt"/>
+                  </a:rPr>
+                  <a:t> exp(−d / λD)</a:t>
+                </a:r>
+                <a:br>
+                  <a:rPr lang="" sz="2000" dirty="0">
+                    <a:latin typeface="+mn-lt"/>
+                  </a:rPr>
+                </a:br>
+                <a:r>
+                  <a:rPr lang="" sz="2000" dirty="0">
+                    <a:latin typeface="+mn-lt"/>
+                  </a:rPr>
+                  <a:t>• PBS-like screening uses λD ≈ 0.8 nm.</a:t>
+                </a:r>
+                <a:br>
+                  <a:rPr lang="" sz="2000" dirty="0">
+                    <a:latin typeface="+mn-lt"/>
+                  </a:rPr>
+                </a:br>
+                <a:r>
+                  <a:rPr lang="" sz="2000" dirty="0">
+                    <a:latin typeface="+mn-lt"/>
+                  </a:rPr>
+                  <a:t>• For PBS-like screening and d ≥ 5 nm, 0/60 screened cases remain detectable.</a:t>
+                </a:r>
+                <a:br>
+                  <a:rPr lang="" sz="2000" dirty="0">
+                    <a:latin typeface="+mn-lt"/>
+                  </a:rPr>
+                </a:br>
+                <a:r>
+                  <a:rPr lang="" sz="2000" dirty="0">
+                    <a:latin typeface="+mn-lt"/>
+                  </a:rPr>
+                  <a:t>• Transport improvement alone cannot overcome electrostatic screening.</a:t>
+                </a:r>
+                <a:endParaRPr lang="tr-TR" sz="2000" dirty="0">
+                  <a:latin typeface="+mn-lt"/>
+                </a:endParaRPr>
+              </a:p>
+              <a:p>
+                <a:pPr eaLnBrk="1" hangingPunct="1"/>
+                <a:r>
+                  <a:rPr lang="en-US" sz="2000" b="1" i="1" dirty="0">
+                    <a:latin typeface="+mn-lt"/>
+                  </a:rPr>
+                  <a:t>Main negative result: even if HER2 reaches the sensor, the signal can be screened out.</a:t>
+                </a:r>
+              </a:p>
+            </p:txBody>
+          </p:sp>
+        </mc:Choice>
+        <mc:Fallback>
+          <p:sp>
+            <p:nvSpPr>
+              <p:cNvPr id="87" name="Text Box 189">
+                <a:extLst>
+                  <a:ext uri="{FF2B5EF4-FFF2-40B4-BE49-F238E27FC236}">
+                    <a16:creationId xmlns:a16="http://schemas.microsoft.com/office/drawing/2014/main" id="{9F5256B7-0FC4-6C42-76FC-1AD14E74B292}"/>
+                  </a:ext>
+                </a:extLst>
+              </p:cNvPr>
+              <p:cNvSpPr txBox="1">
+                <a:spLocks noRot="1" noChangeAspect="1" noMove="1" noResize="1" noEditPoints="1" noAdjustHandles="1" noChangeArrowheads="1" noChangeShapeType="1" noTextEdit="1"/>
+              </p:cNvSpPr>
+              <p:nvPr/>
+            </p:nvSpPr>
+            <p:spPr bwMode="auto">
+              <a:xfrm>
+                <a:off x="32736475" y="18875765"/>
+                <a:ext cx="8787392" cy="2622923"/>
+              </a:xfrm>
+              <a:prstGeom prst="rect">
+                <a:avLst/>
+              </a:prstGeom>
+              <a:blipFill>
+                <a:blip r:embed="rId11"/>
+                <a:stretch>
+                  <a:fillRect/>
+                </a:stretch>
+              </a:blipFill>
+              <a:ln w="12700">
+                <a:solidFill>
+                  <a:schemeClr val="accent1">
+                    <a:lumMod val="75000"/>
+                  </a:schemeClr>
+                </a:solidFill>
+              </a:ln>
+              <a:effectLst/>
+            </p:spPr>
+            <p:txBody>
+              <a:bodyPr/>
+              <a:lstStyle/>
+              <a:p>
+                <a:r>
+                  <a:rPr lang="LID4096">
+                    <a:noFill/>
+                  </a:rPr>
+                  <a:t> </a:t>
+                </a:r>
+              </a:p>
+            </p:txBody>
+          </p:sp>
+        </mc:Fallback>
+      </mc:AlternateContent>
       <p:sp>
         <p:nvSpPr>
           <p:cNvPr id="88" name="Rectangle 87">
@@ -6115,8 +6699,8 @@
         </p:nvSpPr>
         <p:spPr>
           <a:xfrm>
-            <a:off x="7076281" y="26184525"/>
-            <a:ext cx="8787392" cy="1057650"/>
+            <a:off x="2620101" y="25651756"/>
+            <a:ext cx="4968424" cy="1057650"/>
           </a:xfrm>
           <a:prstGeom prst="rect">
             <a:avLst/>
@@ -6162,276 +6746,384 @@
           </a:p>
         </p:txBody>
       </p:sp>
-      <p:sp>
-        <p:nvSpPr>
-          <p:cNvPr id="89" name="Text Box 189">
-            <a:extLst>
-              <a:ext uri="{FF2B5EF4-FFF2-40B4-BE49-F238E27FC236}">
-                <a16:creationId xmlns:a16="http://schemas.microsoft.com/office/drawing/2014/main" id="{09E1D88B-6299-71ED-CD80-319D0E3C8432}"/>
-              </a:ext>
-            </a:extLst>
-          </p:cNvPr>
-          <p:cNvSpPr txBox="1">
-            <a:spLocks noChangeArrowheads="1"/>
-          </p:cNvSpPr>
-          <p:nvPr/>
-        </p:nvSpPr>
-        <p:spPr bwMode="auto">
-          <a:xfrm>
-            <a:off x="7076281" y="27242175"/>
-            <a:ext cx="8787392" cy="2930699"/>
-          </a:xfrm>
-          <a:prstGeom prst="rect">
-            <a:avLst/>
-          </a:prstGeom>
-          <a:solidFill>
-            <a:schemeClr val="bg1"/>
-          </a:solidFill>
-          <a:ln w="12700">
-            <a:solidFill>
-              <a:schemeClr val="accent1">
-                <a:lumMod val="75000"/>
-              </a:schemeClr>
-            </a:solidFill>
-          </a:ln>
-          <a:effectLst/>
-        </p:spPr>
-        <p:txBody>
-          <a:bodyPr wrap="square" lIns="231978" tIns="231978" rIns="231978" bIns="231978">
-            <a:spAutoFit/>
-          </a:bodyPr>
-          <a:lstStyle>
-            <a:lvl1pPr eaLnBrk="0" hangingPunct="0">
-              <a:defRPr sz="2200">
-                <a:solidFill>
-                  <a:schemeClr val="tx1"/>
-                </a:solidFill>
-                <a:latin typeface="Arial" charset="0"/>
-              </a:defRPr>
-            </a:lvl1pPr>
-            <a:lvl2pPr marL="742950" indent="-285750" eaLnBrk="0" hangingPunct="0">
-              <a:defRPr sz="2200">
-                <a:solidFill>
-                  <a:schemeClr val="tx1"/>
-                </a:solidFill>
-                <a:latin typeface="Arial" charset="0"/>
-              </a:defRPr>
-            </a:lvl2pPr>
-            <a:lvl3pPr marL="1143000" indent="-228600" eaLnBrk="0" hangingPunct="0">
-              <a:defRPr sz="2200">
-                <a:solidFill>
-                  <a:schemeClr val="tx1"/>
-                </a:solidFill>
-                <a:latin typeface="Arial" charset="0"/>
-              </a:defRPr>
-            </a:lvl3pPr>
-            <a:lvl4pPr marL="1600200" indent="-228600" eaLnBrk="0" hangingPunct="0">
-              <a:defRPr sz="2200">
-                <a:solidFill>
-                  <a:schemeClr val="tx1"/>
-                </a:solidFill>
-                <a:latin typeface="Arial" charset="0"/>
-              </a:defRPr>
-            </a:lvl4pPr>
-            <a:lvl5pPr marL="2057400" indent="-228600" eaLnBrk="0" hangingPunct="0">
-              <a:defRPr sz="2200">
-                <a:solidFill>
-                  <a:schemeClr val="tx1"/>
-                </a:solidFill>
-                <a:latin typeface="Arial" charset="0"/>
-              </a:defRPr>
-            </a:lvl5pPr>
-            <a:lvl6pPr marL="2514600" indent="-228600" eaLnBrk="0" fontAlgn="base" hangingPunct="0">
-              <a:spcBef>
-                <a:spcPct val="0"/>
-              </a:spcBef>
-              <a:spcAft>
-                <a:spcPct val="0"/>
-              </a:spcAft>
-              <a:defRPr sz="2200">
-                <a:solidFill>
-                  <a:schemeClr val="tx1"/>
-                </a:solidFill>
-                <a:latin typeface="Arial" charset="0"/>
-              </a:defRPr>
-            </a:lvl6pPr>
-            <a:lvl7pPr marL="2971800" indent="-228600" eaLnBrk="0" fontAlgn="base" hangingPunct="0">
-              <a:spcBef>
-                <a:spcPct val="0"/>
-              </a:spcBef>
-              <a:spcAft>
-                <a:spcPct val="0"/>
-              </a:spcAft>
-              <a:defRPr sz="2200">
-                <a:solidFill>
-                  <a:schemeClr val="tx1"/>
-                </a:solidFill>
-                <a:latin typeface="Arial" charset="0"/>
-              </a:defRPr>
-            </a:lvl7pPr>
-            <a:lvl8pPr marL="3429000" indent="-228600" eaLnBrk="0" fontAlgn="base" hangingPunct="0">
-              <a:spcBef>
-                <a:spcPct val="0"/>
-              </a:spcBef>
-              <a:spcAft>
-                <a:spcPct val="0"/>
-              </a:spcAft>
-              <a:defRPr sz="2200">
-                <a:solidFill>
-                  <a:schemeClr val="tx1"/>
-                </a:solidFill>
-                <a:latin typeface="Arial" charset="0"/>
-              </a:defRPr>
-            </a:lvl8pPr>
-            <a:lvl9pPr marL="3886200" indent="-228600" eaLnBrk="0" fontAlgn="base" hangingPunct="0">
-              <a:spcBef>
-                <a:spcPct val="0"/>
-              </a:spcBef>
-              <a:spcAft>
-                <a:spcPct val="0"/>
-              </a:spcAft>
-              <a:defRPr sz="2200">
-                <a:solidFill>
-                  <a:schemeClr val="tx1"/>
-                </a:solidFill>
-                <a:latin typeface="Arial" charset="0"/>
-              </a:defRPr>
-            </a:lvl9pPr>
-          </a:lstStyle>
-          <a:p>
-            <a:pPr eaLnBrk="1" hangingPunct="1"/>
-            <a:r>
-              <a:rPr lang="en-US" sz="2000" dirty="0">
-                <a:latin typeface="+mn-lt"/>
-              </a:rPr>
-              <a:t>• HER2 concentration: 0.5–1000 </a:t>
-            </a:r>
-            <a:r>
-              <a:rPr lang="en-US" sz="2000" dirty="0" err="1">
-                <a:latin typeface="+mn-lt"/>
-              </a:rPr>
-              <a:t>pM</a:t>
-            </a:r>
-            <a:endParaRPr lang="en-US" sz="2000" dirty="0">
-              <a:latin typeface="+mn-lt"/>
-            </a:endParaRPr>
-          </a:p>
-          <a:p>
-            <a:pPr eaLnBrk="1" hangingPunct="1"/>
-            <a:r>
-              <a:rPr lang="en-US" sz="2000" dirty="0">
-                <a:latin typeface="+mn-lt"/>
-              </a:rPr>
-              <a:t>• Baseline C: 10 </a:t>
-            </a:r>
-            <a:r>
-              <a:rPr lang="en-US" sz="2000" dirty="0" err="1">
-                <a:latin typeface="+mn-lt"/>
-              </a:rPr>
-              <a:t>pM</a:t>
-            </a:r>
-            <a:endParaRPr lang="en-US" sz="2000" dirty="0">
-              <a:latin typeface="+mn-lt"/>
-            </a:endParaRPr>
-          </a:p>
-          <a:p>
-            <a:pPr eaLnBrk="1" hangingPunct="1"/>
-            <a:r>
-              <a:rPr lang="en-US" sz="2000" dirty="0">
-                <a:latin typeface="+mn-lt"/>
-              </a:rPr>
-              <a:t>• </a:t>
-            </a:r>
-            <a:r>
-              <a:rPr lang="en-US" sz="2000" dirty="0" err="1">
-                <a:latin typeface="+mn-lt"/>
-              </a:rPr>
-              <a:t>Kd</a:t>
-            </a:r>
-            <a:r>
-              <a:rPr lang="en-US" sz="2000" dirty="0">
-                <a:latin typeface="+mn-lt"/>
-              </a:rPr>
-              <a:t> sweep: 1, 10, 100 </a:t>
-            </a:r>
-            <a:r>
-              <a:rPr lang="en-US" sz="2000" dirty="0" err="1">
-                <a:latin typeface="+mn-lt"/>
-              </a:rPr>
-              <a:t>pM</a:t>
-            </a:r>
-            <a:endParaRPr lang="en-US" sz="2000" dirty="0">
-              <a:latin typeface="+mn-lt"/>
-            </a:endParaRPr>
-          </a:p>
-          <a:p>
-            <a:pPr eaLnBrk="1" hangingPunct="1"/>
-            <a:r>
-              <a:rPr lang="en-US" sz="2000" dirty="0">
-                <a:latin typeface="+mn-lt"/>
-              </a:rPr>
-              <a:t>• M2B velocity: 0 to 1 × 10⁻⁶ m/s</a:t>
-            </a:r>
-          </a:p>
-          <a:p>
-            <a:pPr eaLnBrk="1" hangingPunct="1"/>
-            <a:r>
-              <a:rPr lang="en-US" sz="2000" dirty="0">
-                <a:latin typeface="+mn-lt"/>
-              </a:rPr>
-              <a:t>• </a:t>
-            </a:r>
-            <a:r>
-              <a:rPr lang="el-GR" sz="2000" dirty="0">
-                <a:latin typeface="+mn-lt"/>
-              </a:rPr>
-              <a:t>α0 </a:t>
-            </a:r>
-            <a:r>
-              <a:rPr lang="en-US" sz="2000" dirty="0">
-                <a:latin typeface="+mn-lt"/>
-              </a:rPr>
-              <a:t>sweep: 0.01, 0.03, 0.1</a:t>
-            </a:r>
-          </a:p>
-          <a:p>
-            <a:pPr eaLnBrk="1" hangingPunct="1"/>
-            <a:r>
-              <a:rPr lang="en-US" sz="2000" dirty="0">
-                <a:latin typeface="+mn-lt"/>
-              </a:rPr>
-              <a:t>• Noise floor: 1–100 </a:t>
-            </a:r>
-            <a:r>
-              <a:rPr lang="en-US" sz="2000" dirty="0" err="1">
-                <a:latin typeface="+mn-lt"/>
-              </a:rPr>
-              <a:t>pA</a:t>
-            </a:r>
-            <a:endParaRPr lang="en-US" sz="2000" dirty="0">
-              <a:latin typeface="+mn-lt"/>
-            </a:endParaRPr>
-          </a:p>
-          <a:p>
-            <a:pPr eaLnBrk="1" hangingPunct="1"/>
-            <a:r>
-              <a:rPr lang="en-US" sz="2000" dirty="0">
-                <a:latin typeface="+mn-lt"/>
-              </a:rPr>
-              <a:t>• Debye length: 9.6, 3.0, 0.8 nm</a:t>
-            </a:r>
-          </a:p>
-          <a:p>
-            <a:pPr eaLnBrk="1" hangingPunct="1"/>
-            <a:r>
-              <a:rPr lang="en-US" sz="2000" dirty="0">
-                <a:latin typeface="+mn-lt"/>
-              </a:rPr>
-              <a:t>• Receptor-channel distance: 0.5–10 nm</a:t>
-            </a:r>
-          </a:p>
-        </p:txBody>
-      </p:sp>
+      <mc:AlternateContent xmlns:mc="http://schemas.openxmlformats.org/markup-compatibility/2006">
+        <mc:Choice xmlns:a14="http://schemas.microsoft.com/office/drawing/2010/main" Requires="a14">
+          <p:sp>
+            <p:nvSpPr>
+              <p:cNvPr id="89" name="Text Box 189">
+                <a:extLst>
+                  <a:ext uri="{FF2B5EF4-FFF2-40B4-BE49-F238E27FC236}">
+                    <a16:creationId xmlns:a16="http://schemas.microsoft.com/office/drawing/2014/main" id="{09E1D88B-6299-71ED-CD80-319D0E3C8432}"/>
+                  </a:ext>
+                </a:extLst>
+              </p:cNvPr>
+              <p:cNvSpPr txBox="1">
+                <a:spLocks noChangeArrowheads="1"/>
+              </p:cNvSpPr>
+              <p:nvPr/>
+            </p:nvSpPr>
+            <p:spPr bwMode="auto">
+              <a:xfrm>
+                <a:off x="2620101" y="26709406"/>
+                <a:ext cx="4968424" cy="2930699"/>
+              </a:xfrm>
+              <a:prstGeom prst="rect">
+                <a:avLst/>
+              </a:prstGeom>
+              <a:solidFill>
+                <a:schemeClr val="bg1"/>
+              </a:solidFill>
+              <a:ln w="12700">
+                <a:solidFill>
+                  <a:schemeClr val="accent1">
+                    <a:lumMod val="75000"/>
+                  </a:schemeClr>
+                </a:solidFill>
+              </a:ln>
+              <a:effectLst/>
+            </p:spPr>
+            <p:txBody>
+              <a:bodyPr wrap="square" lIns="231978" tIns="231978" rIns="231978" bIns="231978">
+                <a:spAutoFit/>
+              </a:bodyPr>
+              <a:lstStyle>
+                <a:lvl1pPr eaLnBrk="0" hangingPunct="0">
+                  <a:defRPr sz="2200">
+                    <a:solidFill>
+                      <a:schemeClr val="tx1"/>
+                    </a:solidFill>
+                    <a:latin typeface="Arial" charset="0"/>
+                  </a:defRPr>
+                </a:lvl1pPr>
+                <a:lvl2pPr marL="742950" indent="-285750" eaLnBrk="0" hangingPunct="0">
+                  <a:defRPr sz="2200">
+                    <a:solidFill>
+                      <a:schemeClr val="tx1"/>
+                    </a:solidFill>
+                    <a:latin typeface="Arial" charset="0"/>
+                  </a:defRPr>
+                </a:lvl2pPr>
+                <a:lvl3pPr marL="1143000" indent="-228600" eaLnBrk="0" hangingPunct="0">
+                  <a:defRPr sz="2200">
+                    <a:solidFill>
+                      <a:schemeClr val="tx1"/>
+                    </a:solidFill>
+                    <a:latin typeface="Arial" charset="0"/>
+                  </a:defRPr>
+                </a:lvl3pPr>
+                <a:lvl4pPr marL="1600200" indent="-228600" eaLnBrk="0" hangingPunct="0">
+                  <a:defRPr sz="2200">
+                    <a:solidFill>
+                      <a:schemeClr val="tx1"/>
+                    </a:solidFill>
+                    <a:latin typeface="Arial" charset="0"/>
+                  </a:defRPr>
+                </a:lvl4pPr>
+                <a:lvl5pPr marL="2057400" indent="-228600" eaLnBrk="0" hangingPunct="0">
+                  <a:defRPr sz="2200">
+                    <a:solidFill>
+                      <a:schemeClr val="tx1"/>
+                    </a:solidFill>
+                    <a:latin typeface="Arial" charset="0"/>
+                  </a:defRPr>
+                </a:lvl5pPr>
+                <a:lvl6pPr marL="2514600" indent="-228600" eaLnBrk="0" fontAlgn="base" hangingPunct="0">
+                  <a:spcBef>
+                    <a:spcPct val="0"/>
+                  </a:spcBef>
+                  <a:spcAft>
+                    <a:spcPct val="0"/>
+                  </a:spcAft>
+                  <a:defRPr sz="2200">
+                    <a:solidFill>
+                      <a:schemeClr val="tx1"/>
+                    </a:solidFill>
+                    <a:latin typeface="Arial" charset="0"/>
+                  </a:defRPr>
+                </a:lvl6pPr>
+                <a:lvl7pPr marL="2971800" indent="-228600" eaLnBrk="0" fontAlgn="base" hangingPunct="0">
+                  <a:spcBef>
+                    <a:spcPct val="0"/>
+                  </a:spcBef>
+                  <a:spcAft>
+                    <a:spcPct val="0"/>
+                  </a:spcAft>
+                  <a:defRPr sz="2200">
+                    <a:solidFill>
+                      <a:schemeClr val="tx1"/>
+                    </a:solidFill>
+                    <a:latin typeface="Arial" charset="0"/>
+                  </a:defRPr>
+                </a:lvl7pPr>
+                <a:lvl8pPr marL="3429000" indent="-228600" eaLnBrk="0" fontAlgn="base" hangingPunct="0">
+                  <a:spcBef>
+                    <a:spcPct val="0"/>
+                  </a:spcBef>
+                  <a:spcAft>
+                    <a:spcPct val="0"/>
+                  </a:spcAft>
+                  <a:defRPr sz="2200">
+                    <a:solidFill>
+                      <a:schemeClr val="tx1"/>
+                    </a:solidFill>
+                    <a:latin typeface="Arial" charset="0"/>
+                  </a:defRPr>
+                </a:lvl8pPr>
+                <a:lvl9pPr marL="3886200" indent="-228600" eaLnBrk="0" fontAlgn="base" hangingPunct="0">
+                  <a:spcBef>
+                    <a:spcPct val="0"/>
+                  </a:spcBef>
+                  <a:spcAft>
+                    <a:spcPct val="0"/>
+                  </a:spcAft>
+                  <a:defRPr sz="2200">
+                    <a:solidFill>
+                      <a:schemeClr val="tx1"/>
+                    </a:solidFill>
+                    <a:latin typeface="Arial" charset="0"/>
+                  </a:defRPr>
+                </a:lvl9pPr>
+              </a:lstStyle>
+              <a:p>
+                <a:pPr eaLnBrk="1" hangingPunct="1"/>
+                <a:r>
+                  <a:rPr lang="en-US" sz="2000" dirty="0">
+                    <a:latin typeface="+mn-lt"/>
+                  </a:rPr>
+                  <a:t>• HER2 concentration: 0.5–1000 </a:t>
+                </a:r>
+                <a:r>
+                  <a:rPr lang="en-US" sz="2000" dirty="0" err="1">
+                    <a:latin typeface="+mn-lt"/>
+                  </a:rPr>
+                  <a:t>pM</a:t>
+                </a:r>
+                <a:endParaRPr lang="en-US" sz="2000" dirty="0">
+                  <a:latin typeface="+mn-lt"/>
+                </a:endParaRPr>
+              </a:p>
+              <a:p>
+                <a:pPr eaLnBrk="1" hangingPunct="1"/>
+                <a:r>
+                  <a:rPr lang="en-US" sz="2000" dirty="0">
+                    <a:latin typeface="+mn-lt"/>
+                  </a:rPr>
+                  <a:t>• Baseline C: 10 </a:t>
+                </a:r>
+                <a:r>
+                  <a:rPr lang="en-US" sz="2000" dirty="0" err="1">
+                    <a:latin typeface="+mn-lt"/>
+                  </a:rPr>
+                  <a:t>pM</a:t>
+                </a:r>
+                <a:endParaRPr lang="en-US" sz="2000" dirty="0">
+                  <a:latin typeface="+mn-lt"/>
+                </a:endParaRPr>
+              </a:p>
+              <a:p>
+                <a:pPr eaLnBrk="1" hangingPunct="1"/>
+                <a:r>
+                  <a:rPr lang="en-US" sz="2000" dirty="0">
+                    <a:latin typeface="+mn-lt"/>
+                  </a:rPr>
+                  <a:t>• </a:t>
+                </a:r>
+                <a14:m>
+                  <m:oMath xmlns:m="http://schemas.openxmlformats.org/officeDocument/2006/math">
+                    <m:sSub>
+                      <m:sSubPr>
+                        <m:ctrlPr>
+                          <a:rPr lang="LID4096" sz="2000" i="1" smtClean="0">
+                            <a:latin typeface="Cambria Math" panose="02040503050406030204" pitchFamily="18" charset="0"/>
+                          </a:rPr>
+                        </m:ctrlPr>
+                      </m:sSubPr>
+                      <m:e>
+                        <m:r>
+                          <a:rPr lang="LID4096" sz="2000" i="1" smtClean="0">
+                            <a:latin typeface="Cambria Math" panose="02040503050406030204" pitchFamily="18" charset="0"/>
+                          </a:rPr>
+                          <m:t>𝐾</m:t>
+                        </m:r>
+                      </m:e>
+                      <m:sub>
+                        <m:r>
+                          <a:rPr lang="LID4096" sz="2000" i="1" smtClean="0">
+                            <a:latin typeface="Cambria Math" panose="02040503050406030204" pitchFamily="18" charset="0"/>
+                          </a:rPr>
+                          <m:t>𝐷</m:t>
+                        </m:r>
+                      </m:sub>
+                    </m:sSub>
+                  </m:oMath>
+                </a14:m>
+                <a:r>
+                  <a:rPr lang="en-US" sz="2000" dirty="0">
+                    <a:latin typeface="+mn-lt"/>
+                  </a:rPr>
+                  <a:t> sweep: 1, 10, 100 </a:t>
+                </a:r>
+                <a:r>
+                  <a:rPr lang="en-US" sz="2000" dirty="0" err="1">
+                    <a:latin typeface="+mn-lt"/>
+                  </a:rPr>
+                  <a:t>pM</a:t>
+                </a:r>
+                <a:endParaRPr lang="en-US" sz="2000" dirty="0">
+                  <a:latin typeface="+mn-lt"/>
+                </a:endParaRPr>
+              </a:p>
+              <a:p>
+                <a:pPr eaLnBrk="1" hangingPunct="1"/>
+                <a:r>
+                  <a:rPr lang="en-US" sz="2000" dirty="0">
+                    <a:latin typeface="+mn-lt"/>
+                  </a:rPr>
+                  <a:t>• M2B velocity: 0 to 1 × 10⁻⁶ m/s</a:t>
+                </a:r>
+              </a:p>
+              <a:p>
+                <a:pPr eaLnBrk="1" hangingPunct="1"/>
+                <a:r>
+                  <a:rPr lang="en-US" sz="2000" dirty="0">
+                    <a:latin typeface="+mn-lt"/>
+                  </a:rPr>
+                  <a:t>• </a:t>
+                </a:r>
+                <a14:m>
+                  <m:oMath xmlns:m="http://schemas.openxmlformats.org/officeDocument/2006/math">
+                    <m:sSub>
+                      <m:sSubPr>
+                        <m:ctrlPr>
+                          <a:rPr lang="LID4096" sz="2000" i="1" smtClean="0">
+                            <a:latin typeface="Cambria Math" panose="02040503050406030204" pitchFamily="18" charset="0"/>
+                          </a:rPr>
+                        </m:ctrlPr>
+                      </m:sSubPr>
+                      <m:e>
+                        <m:r>
+                          <a:rPr lang="LID4096" sz="2000" i="1" smtClean="0">
+                            <a:latin typeface="Cambria Math" panose="02040503050406030204" pitchFamily="18" charset="0"/>
+                          </a:rPr>
+                          <m:t>𝛼</m:t>
+                        </m:r>
+                      </m:e>
+                      <m:sub>
+                        <m:r>
+                          <a:rPr lang="LID4096" sz="2000" i="1" smtClean="0">
+                            <a:latin typeface="Cambria Math" panose="02040503050406030204" pitchFamily="18" charset="0"/>
+                          </a:rPr>
+                          <m:t>0</m:t>
+                        </m:r>
+                      </m:sub>
+                    </m:sSub>
+                  </m:oMath>
+                </a14:m>
+                <a:r>
+                  <a:rPr lang="el-GR" sz="2000" dirty="0">
+                    <a:latin typeface="+mn-lt"/>
+                  </a:rPr>
+                  <a:t> </a:t>
+                </a:r>
+                <a:r>
+                  <a:rPr lang="en-US" sz="2000" dirty="0">
+                    <a:latin typeface="+mn-lt"/>
+                  </a:rPr>
+                  <a:t>sweep: 0.01, 0.03, 0.1</a:t>
+                </a:r>
+              </a:p>
+              <a:p>
+                <a:pPr eaLnBrk="1" hangingPunct="1"/>
+                <a:r>
+                  <a:rPr lang="en-US" sz="2000" dirty="0">
+                    <a:latin typeface="+mn-lt"/>
+                  </a:rPr>
+                  <a:t>• Noise floor: 1–100 </a:t>
+                </a:r>
+                <a:r>
+                  <a:rPr lang="en-US" sz="2000" dirty="0" err="1">
+                    <a:latin typeface="+mn-lt"/>
+                  </a:rPr>
+                  <a:t>pA</a:t>
+                </a:r>
+                <a:endParaRPr lang="en-US" sz="2000" dirty="0">
+                  <a:latin typeface="+mn-lt"/>
+                </a:endParaRPr>
+              </a:p>
+              <a:p>
+                <a:pPr eaLnBrk="1" hangingPunct="1"/>
+                <a:r>
+                  <a:rPr lang="en-US" sz="2000" dirty="0">
+                    <a:latin typeface="+mn-lt"/>
+                  </a:rPr>
+                  <a:t>• Debye length: 9.6, 3.0, 0.8 nm</a:t>
+                </a:r>
+              </a:p>
+              <a:p>
+                <a:pPr eaLnBrk="1" hangingPunct="1"/>
+                <a:r>
+                  <a:rPr lang="en-US" sz="2000" dirty="0">
+                    <a:latin typeface="+mn-lt"/>
+                  </a:rPr>
+                  <a:t>• Receptor-channel distance: 0.5–10 nm</a:t>
+                </a:r>
+              </a:p>
+            </p:txBody>
+          </p:sp>
+        </mc:Choice>
+        <mc:Fallback>
+          <p:sp>
+            <p:nvSpPr>
+              <p:cNvPr id="89" name="Text Box 189">
+                <a:extLst>
+                  <a:ext uri="{FF2B5EF4-FFF2-40B4-BE49-F238E27FC236}">
+                    <a16:creationId xmlns:a16="http://schemas.microsoft.com/office/drawing/2014/main" id="{09E1D88B-6299-71ED-CD80-319D0E3C8432}"/>
+                  </a:ext>
+                </a:extLst>
+              </p:cNvPr>
+              <p:cNvSpPr txBox="1">
+                <a:spLocks noRot="1" noChangeAspect="1" noMove="1" noResize="1" noEditPoints="1" noAdjustHandles="1" noChangeArrowheads="1" noChangeShapeType="1" noTextEdit="1"/>
+              </p:cNvSpPr>
+              <p:nvPr/>
+            </p:nvSpPr>
+            <p:spPr bwMode="auto">
+              <a:xfrm>
+                <a:off x="2620101" y="26709406"/>
+                <a:ext cx="4968424" cy="2930699"/>
+              </a:xfrm>
+              <a:prstGeom prst="rect">
+                <a:avLst/>
+              </a:prstGeom>
+              <a:blipFill>
+                <a:blip r:embed="rId12"/>
+                <a:stretch>
+                  <a:fillRect/>
+                </a:stretch>
+              </a:blipFill>
+              <a:ln w="12700">
+                <a:solidFill>
+                  <a:schemeClr val="accent1">
+                    <a:lumMod val="75000"/>
+                  </a:schemeClr>
+                </a:solidFill>
+              </a:ln>
+              <a:effectLst/>
+            </p:spPr>
+            <p:txBody>
+              <a:bodyPr/>
+              <a:lstStyle/>
+              <a:p>
+                <a:r>
+                  <a:rPr lang="LID4096">
+                    <a:noFill/>
+                  </a:rPr>
+                  <a:t> </a:t>
+                </a:r>
+              </a:p>
+            </p:txBody>
+          </p:sp>
+        </mc:Fallback>
+      </mc:AlternateContent>
       <p:pic>
         <p:nvPicPr>
           <p:cNvPr id="91" name="Picture 90">
@@ -6447,7 +7139,7 @@
           <p:nvPr/>
         </p:nvPicPr>
         <p:blipFill>
-          <a:blip r:embed="rId7"/>
+          <a:blip r:embed="rId13"/>
           <a:stretch>
             <a:fillRect/>
           </a:stretch>
@@ -6477,7 +7169,7 @@
           <p:nvPr/>
         </p:nvPicPr>
         <p:blipFill>
-          <a:blip r:embed="rId8"/>
+          <a:blip r:embed="rId14"/>
           <a:stretch>
             <a:fillRect/>
           </a:stretch>
@@ -6507,7 +7199,7 @@
           <p:nvPr/>
         </p:nvPicPr>
         <p:blipFill>
-          <a:blip r:embed="rId9"/>
+          <a:blip r:embed="rId15"/>
           <a:stretch>
             <a:fillRect/>
           </a:stretch>
@@ -6537,7 +7229,7 @@
           <p:nvPr/>
         </p:nvPicPr>
         <p:blipFill>
-          <a:blip r:embed="rId10"/>
+          <a:blip r:embed="rId16"/>
           <a:stretch>
             <a:fillRect/>
           </a:stretch>
@@ -6567,7 +7259,7 @@
           <p:nvPr/>
         </p:nvPicPr>
         <p:blipFill>
-          <a:blip r:embed="rId11"/>
+          <a:blip r:embed="rId17"/>
           <a:stretch>
             <a:fillRect/>
           </a:stretch>
@@ -6597,7 +7289,7 @@
           <p:nvPr/>
         </p:nvPicPr>
         <p:blipFill>
-          <a:blip r:embed="rId12"/>
+          <a:blip r:embed="rId18"/>
           <a:stretch>
             <a:fillRect/>
           </a:stretch>
@@ -6627,7 +7319,7 @@
           <p:nvPr/>
         </p:nvPicPr>
         <p:blipFill>
-          <a:blip r:embed="rId13"/>
+          <a:blip r:embed="rId19"/>
           <a:stretch>
             <a:fillRect/>
           </a:stretch>
@@ -6657,7 +7349,7 @@
           <p:nvPr/>
         </p:nvPicPr>
         <p:blipFill>
-          <a:blip r:embed="rId14"/>
+          <a:blip r:embed="rId20"/>
           <a:stretch>
             <a:fillRect/>
           </a:stretch>
@@ -6672,6 +7364,297 @@
           </a:prstGeom>
         </p:spPr>
       </p:pic>
+      <p:sp>
+        <p:nvSpPr>
+          <p:cNvPr id="2" name="Rectangle 1">
+            <a:extLst>
+              <a:ext uri="{FF2B5EF4-FFF2-40B4-BE49-F238E27FC236}">
+                <a16:creationId xmlns:a16="http://schemas.microsoft.com/office/drawing/2014/main" id="{833143D3-789F-60CC-79A6-A4B4595250D7}"/>
+              </a:ext>
+            </a:extLst>
+          </p:cNvPr>
+          <p:cNvSpPr/>
+          <p:nvPr/>
+        </p:nvSpPr>
+        <p:spPr>
+          <a:xfrm>
+            <a:off x="23524801" y="25651756"/>
+            <a:ext cx="7562488" cy="1057650"/>
+          </a:xfrm>
+          <a:prstGeom prst="rect">
+            <a:avLst/>
+          </a:prstGeom>
+          <a:solidFill>
+            <a:schemeClr val="accent3">
+              <a:lumMod val="75000"/>
+            </a:schemeClr>
+          </a:solidFill>
+        </p:spPr>
+        <p:style>
+          <a:lnRef idx="2">
+            <a:schemeClr val="accent1">
+              <a:shade val="50000"/>
+            </a:schemeClr>
+          </a:lnRef>
+          <a:fillRef idx="1">
+            <a:schemeClr val="accent1"/>
+          </a:fillRef>
+          <a:effectRef idx="0">
+            <a:schemeClr val="accent1"/>
+          </a:effectRef>
+          <a:fontRef idx="minor">
+            <a:schemeClr val="lt1"/>
+          </a:fontRef>
+        </p:style>
+        <p:txBody>
+          <a:bodyPr lIns="115988" tIns="57994" rIns="115988" bIns="57994" rtlCol="0" anchor="ctr"/>
+          <a:lstStyle/>
+          <a:p>
+            <a:pPr algn="ctr"/>
+            <a:r>
+              <a:rPr lang="en-US" sz="4000" b="1">
+                <a:solidFill>
+                  <a:schemeClr val="accent3">
+                    <a:lumMod val="20000"/>
+                    <a:lumOff val="80000"/>
+                  </a:schemeClr>
+                </a:solidFill>
+              </a:rPr>
+              <a:t>Limitations &amp; Future Work</a:t>
+            </a:r>
+            <a:endParaRPr lang="en-US" sz="4000" b="1" dirty="0">
+              <a:solidFill>
+                <a:schemeClr val="accent3">
+                  <a:lumMod val="20000"/>
+                  <a:lumOff val="80000"/>
+                </a:schemeClr>
+              </a:solidFill>
+            </a:endParaRPr>
+          </a:p>
+        </p:txBody>
+      </p:sp>
+      <p:sp>
+        <p:nvSpPr>
+          <p:cNvPr id="3" name="Text Box 189">
+            <a:extLst>
+              <a:ext uri="{FF2B5EF4-FFF2-40B4-BE49-F238E27FC236}">
+                <a16:creationId xmlns:a16="http://schemas.microsoft.com/office/drawing/2014/main" id="{2DD465FA-A0E2-94D1-062E-F43DC354945B}"/>
+              </a:ext>
+            </a:extLst>
+          </p:cNvPr>
+          <p:cNvSpPr txBox="1">
+            <a:spLocks noChangeArrowheads="1"/>
+          </p:cNvSpPr>
+          <p:nvPr/>
+        </p:nvSpPr>
+        <p:spPr bwMode="auto">
+          <a:xfrm>
+            <a:off x="23524801" y="26709406"/>
+            <a:ext cx="7562488" cy="2930699"/>
+          </a:xfrm>
+          <a:prstGeom prst="rect">
+            <a:avLst/>
+          </a:prstGeom>
+          <a:solidFill>
+            <a:schemeClr val="bg1"/>
+          </a:solidFill>
+          <a:ln w="12700">
+            <a:solidFill>
+              <a:schemeClr val="accent1">
+                <a:lumMod val="75000"/>
+              </a:schemeClr>
+            </a:solidFill>
+          </a:ln>
+          <a:effectLst/>
+        </p:spPr>
+        <p:txBody>
+          <a:bodyPr wrap="square" lIns="231978" tIns="231978" rIns="231978" bIns="231978">
+            <a:spAutoFit/>
+          </a:bodyPr>
+          <a:lstStyle>
+            <a:lvl1pPr eaLnBrk="0" hangingPunct="0">
+              <a:defRPr sz="2200">
+                <a:solidFill>
+                  <a:schemeClr val="tx1"/>
+                </a:solidFill>
+                <a:latin typeface="Arial" charset="0"/>
+              </a:defRPr>
+            </a:lvl1pPr>
+            <a:lvl2pPr marL="742950" indent="-285750" eaLnBrk="0" hangingPunct="0">
+              <a:defRPr sz="2200">
+                <a:solidFill>
+                  <a:schemeClr val="tx1"/>
+                </a:solidFill>
+                <a:latin typeface="Arial" charset="0"/>
+              </a:defRPr>
+            </a:lvl2pPr>
+            <a:lvl3pPr marL="1143000" indent="-228600" eaLnBrk="0" hangingPunct="0">
+              <a:defRPr sz="2200">
+                <a:solidFill>
+                  <a:schemeClr val="tx1"/>
+                </a:solidFill>
+                <a:latin typeface="Arial" charset="0"/>
+              </a:defRPr>
+            </a:lvl3pPr>
+            <a:lvl4pPr marL="1600200" indent="-228600" eaLnBrk="0" hangingPunct="0">
+              <a:defRPr sz="2200">
+                <a:solidFill>
+                  <a:schemeClr val="tx1"/>
+                </a:solidFill>
+                <a:latin typeface="Arial" charset="0"/>
+              </a:defRPr>
+            </a:lvl4pPr>
+            <a:lvl5pPr marL="2057400" indent="-228600" eaLnBrk="0" hangingPunct="0">
+              <a:defRPr sz="2200">
+                <a:solidFill>
+                  <a:schemeClr val="tx1"/>
+                </a:solidFill>
+                <a:latin typeface="Arial" charset="0"/>
+              </a:defRPr>
+            </a:lvl5pPr>
+            <a:lvl6pPr marL="2514600" indent="-228600" eaLnBrk="0" fontAlgn="base" hangingPunct="0">
+              <a:spcBef>
+                <a:spcPct val="0"/>
+              </a:spcBef>
+              <a:spcAft>
+                <a:spcPct val="0"/>
+              </a:spcAft>
+              <a:defRPr sz="2200">
+                <a:solidFill>
+                  <a:schemeClr val="tx1"/>
+                </a:solidFill>
+                <a:latin typeface="Arial" charset="0"/>
+              </a:defRPr>
+            </a:lvl6pPr>
+            <a:lvl7pPr marL="2971800" indent="-228600" eaLnBrk="0" fontAlgn="base" hangingPunct="0">
+              <a:spcBef>
+                <a:spcPct val="0"/>
+              </a:spcBef>
+              <a:spcAft>
+                <a:spcPct val="0"/>
+              </a:spcAft>
+              <a:defRPr sz="2200">
+                <a:solidFill>
+                  <a:schemeClr val="tx1"/>
+                </a:solidFill>
+                <a:latin typeface="Arial" charset="0"/>
+              </a:defRPr>
+            </a:lvl7pPr>
+            <a:lvl8pPr marL="3429000" indent="-228600" eaLnBrk="0" fontAlgn="base" hangingPunct="0">
+              <a:spcBef>
+                <a:spcPct val="0"/>
+              </a:spcBef>
+              <a:spcAft>
+                <a:spcPct val="0"/>
+              </a:spcAft>
+              <a:defRPr sz="2200">
+                <a:solidFill>
+                  <a:schemeClr val="tx1"/>
+                </a:solidFill>
+                <a:latin typeface="Arial" charset="0"/>
+              </a:defRPr>
+            </a:lvl8pPr>
+            <a:lvl9pPr marL="3886200" indent="-228600" eaLnBrk="0" fontAlgn="base" hangingPunct="0">
+              <a:spcBef>
+                <a:spcPct val="0"/>
+              </a:spcBef>
+              <a:spcAft>
+                <a:spcPct val="0"/>
+              </a:spcAft>
+              <a:defRPr sz="2200">
+                <a:solidFill>
+                  <a:schemeClr val="tx1"/>
+                </a:solidFill>
+                <a:latin typeface="Arial" charset="0"/>
+              </a:defRPr>
+            </a:lvl9pPr>
+          </a:lstStyle>
+          <a:p>
+            <a:pPr eaLnBrk="1" hangingPunct="1"/>
+            <a:r>
+              <a:rPr lang="en-US" sz="2000" dirty="0">
+                <a:latin typeface="+mn-lt"/>
+              </a:rPr>
+              <a:t>• </a:t>
+            </a:r>
+            <a:r>
+              <a:rPr lang="en-US" sz="2000" b="1" dirty="0">
+                <a:latin typeface="+mn-lt"/>
+              </a:rPr>
+              <a:t>Simulation-only study</a:t>
+            </a:r>
+            <a:r>
+              <a:rPr lang="en-US" sz="2000" dirty="0">
+                <a:latin typeface="+mn-lt"/>
+              </a:rPr>
+              <a:t>; no fabricated GFET or clinical validation.</a:t>
+            </a:r>
+          </a:p>
+          <a:p>
+            <a:pPr eaLnBrk="1" hangingPunct="1"/>
+            <a:r>
+              <a:rPr lang="en-US" sz="2000" dirty="0">
+                <a:latin typeface="+mn-lt"/>
+              </a:rPr>
+              <a:t>• M2B uses </a:t>
+            </a:r>
+            <a:r>
+              <a:rPr lang="en-US" sz="2000" b="1" dirty="0">
+                <a:latin typeface="+mn-lt"/>
+              </a:rPr>
+              <a:t>prescribed velocity</a:t>
+            </a:r>
+            <a:r>
+              <a:rPr lang="en-US" sz="2000" dirty="0">
+                <a:latin typeface="+mn-lt"/>
+              </a:rPr>
+              <a:t>, not validated Darcy/Brinkman lymph flow.</a:t>
+            </a:r>
+          </a:p>
+          <a:p>
+            <a:pPr eaLnBrk="1" hangingPunct="1"/>
+            <a:r>
+              <a:rPr lang="en-US" sz="2000" dirty="0">
+                <a:latin typeface="+mn-lt"/>
+              </a:rPr>
+              <a:t>• GFET response and Debye screening are </a:t>
+            </a:r>
+            <a:r>
+              <a:rPr lang="en-US" sz="2000" b="1" dirty="0">
+                <a:latin typeface="+mn-lt"/>
+              </a:rPr>
+              <a:t>analytical feasibility models</a:t>
+            </a:r>
+            <a:r>
+              <a:rPr lang="en-US" sz="2000" dirty="0">
+                <a:latin typeface="+mn-lt"/>
+              </a:rPr>
+              <a:t>.</a:t>
+            </a:r>
+          </a:p>
+          <a:p>
+            <a:pPr eaLnBrk="1" hangingPunct="1"/>
+            <a:r>
+              <a:rPr lang="en-US" sz="2000" dirty="0">
+                <a:latin typeface="+mn-lt"/>
+              </a:rPr>
+              <a:t>• </a:t>
+            </a:r>
+            <a:r>
+              <a:rPr lang="en-US" sz="2000" b="1" dirty="0">
+                <a:latin typeface="+mn-lt"/>
+              </a:rPr>
+              <a:t>Future work</a:t>
+            </a:r>
+            <a:r>
+              <a:rPr lang="en-US" sz="2000" dirty="0">
+                <a:latin typeface="+mn-lt"/>
+              </a:rPr>
+              <a:t>: experimental binding validation, low-noise readout, shorter receptor-channel distance, and improved flow/electrostatic modeling.</a:t>
+            </a:r>
+          </a:p>
+        </p:txBody>
+      </p:sp>
     </p:spTree>
     <p:extLst>
       <p:ext uri="{BB962C8B-B14F-4D97-AF65-F5344CB8AC3E}">

</xml_diff>